<commit_message>
Expand to 6 slides — split genetic screens and AI chat
Co-Authored-By: Claude Opus 4.6 <noreply@anthropic.com>
</commit_message>
<xml_diff>
--- a/HTSplotter_Summary.pptx
+++ b/HTSplotter_Summary.pptx
@@ -10,6 +10,7 @@
     <p:sldId id="258" r:id="rId9"/>
     <p:sldId id="259" r:id="rId10"/>
     <p:sldId id="260" r:id="rId11"/>
+    <p:sldId id="261" r:id="rId12"/>
   </p:sldIdLst>
   <p:sldSz cx="12188952" cy="6858000" type="screen4x3"/>
   <p:notesSz cx="6858000" cy="9144000"/>
@@ -3778,7 +3779,7 @@
                   <a:srgbClr val="FFFFFF"/>
                 </a:solidFill>
               </a:rPr>
-              <a:t>Slide 1 of 5</a:t>
+              <a:t>Slide 1 of 6</a:t>
             </a:r>
           </a:p>
         </p:txBody>
@@ -5787,7 +5788,7 @@
                   <a:srgbClr val="FFFFFF"/>
                 </a:solidFill>
               </a:rPr>
-              <a:t>Slide 2 of 5</a:t>
+              <a:t>Slide 2 of 6</a:t>
             </a:r>
           </a:p>
         </p:txBody>
@@ -8272,7 +8273,7 @@
                   <a:srgbClr val="FFFFFF"/>
                 </a:solidFill>
               </a:rPr>
-              <a:t>Slide 3 of 5</a:t>
+              <a:t>Slide 3 of 6</a:t>
             </a:r>
           </a:p>
         </p:txBody>
@@ -9432,7 +9433,7 @@
                   <a:srgbClr val="FFFFFF"/>
                 </a:solidFill>
               </a:rPr>
-              <a:t>Slide 4 of 5</a:t>
+              <a:t>Slide 4 of 6</a:t>
             </a:r>
           </a:p>
         </p:txBody>
@@ -9612,7 +9613,7 @@
                   <a:srgbClr val="FFFFFF"/>
                 </a:solidFill>
               </a:rPr>
-              <a:t>Genetic Perturbagen Screens &amp; AI-Assisted Interpretation</a:t>
+              <a:t>Genetic Perturbagen Screen Results</a:t>
             </a:r>
           </a:p>
         </p:txBody>
@@ -9659,8 +9660,8 @@
         </p:nvSpPr>
         <p:spPr>
           <a:xfrm>
-            <a:off x="274320" y="914400"/>
-            <a:ext cx="5577840" cy="5532120"/>
+            <a:off x="274320" y="987552"/>
+            <a:ext cx="11640312" cy="2633472"/>
           </a:xfrm>
           <a:prstGeom prst="rect">
             <a:avLst/>
@@ -9698,14 +9699,57 @@
       </p:sp>
       <p:sp>
         <p:nvSpPr>
-          <p:cNvPr id="7" name="TextBox 6"/>
-          <p:cNvSpPr txBox="1"/>
-          <p:nvPr/>
-        </p:nvSpPr>
-        <p:spPr>
-          <a:xfrm>
-            <a:off x="457200" y="978408"/>
-            <a:ext cx="5212080" cy="347472"/>
+          <p:cNvPr id="7" name="Rectangle 6"/>
+          <p:cNvSpPr/>
+          <p:nvPr/>
+        </p:nvSpPr>
+        <p:spPr>
+          <a:xfrm>
+            <a:off x="274320" y="987552"/>
+            <a:ext cx="11640312" cy="475488"/>
+          </a:xfrm>
+          <a:prstGeom prst="rect">
+            <a:avLst/>
+          </a:prstGeom>
+          <a:solidFill>
+            <a:srgbClr val="2E75B6"/>
+          </a:solidFill>
+          <a:ln>
+            <a:noFill/>
+          </a:ln>
+        </p:spPr>
+        <p:style>
+          <a:lnRef idx="1">
+            <a:schemeClr val="accent1"/>
+          </a:lnRef>
+          <a:fillRef idx="3">
+            <a:schemeClr val="accent1"/>
+          </a:fillRef>
+          <a:effectRef idx="2">
+            <a:schemeClr val="accent1"/>
+          </a:effectRef>
+          <a:fontRef idx="minor">
+            <a:schemeClr val="lt1"/>
+          </a:fontRef>
+        </p:style>
+        <p:txBody>
+          <a:bodyPr rtlCol="0" anchor="ctr"/>
+          <a:lstStyle/>
+          <a:p>
+            <a:pPr algn="ctr"/>
+          </a:p>
+        </p:txBody>
+      </p:sp>
+      <p:sp>
+        <p:nvSpPr>
+          <p:cNvPr id="8" name="TextBox 7"/>
+          <p:cNvSpPr txBox="1"/>
+          <p:nvPr/>
+        </p:nvSpPr>
+        <p:spPr>
+          <a:xfrm>
+            <a:off x="457200" y="1060704"/>
+            <a:ext cx="8686800" cy="329184"/>
           </a:xfrm>
           <a:prstGeom prst="rect">
             <a:avLst/>
@@ -9722,24 +9766,233 @@
             <a:r>
               <a:rPr sz="1400" b="1" i="0">
                 <a:solidFill>
+                  <a:srgbClr val="FFFFFF"/>
+                </a:solidFill>
+              </a:rPr>
+              <a:t>1 Time Point  |  1 Control  (48 h endpoint)</a:t>
+            </a:r>
+          </a:p>
+        </p:txBody>
+      </p:sp>
+      <p:sp>
+        <p:nvSpPr>
+          <p:cNvPr id="9" name="Rectangle 8"/>
+          <p:cNvSpPr/>
+          <p:nvPr/>
+        </p:nvSpPr>
+        <p:spPr>
+          <a:xfrm>
+            <a:off x="9601200" y="1078992"/>
+            <a:ext cx="2148840" cy="292608"/>
+          </a:xfrm>
+          <a:prstGeom prst="rect">
+            <a:avLst/>
+          </a:prstGeom>
+          <a:solidFill>
+            <a:srgbClr val="1F8678"/>
+          </a:solidFill>
+          <a:ln>
+            <a:noFill/>
+          </a:ln>
+        </p:spPr>
+        <p:style>
+          <a:lnRef idx="1">
+            <a:schemeClr val="accent1"/>
+          </a:lnRef>
+          <a:fillRef idx="3">
+            <a:schemeClr val="accent1"/>
+          </a:fillRef>
+          <a:effectRef idx="2">
+            <a:schemeClr val="accent1"/>
+          </a:effectRef>
+          <a:fontRef idx="minor">
+            <a:schemeClr val="lt1"/>
+          </a:fontRef>
+        </p:style>
+        <p:txBody>
+          <a:bodyPr rtlCol="0" anchor="ctr"/>
+          <a:lstStyle/>
+          <a:p>
+            <a:pPr algn="ctr"/>
+          </a:p>
+        </p:txBody>
+      </p:sp>
+      <p:sp>
+        <p:nvSpPr>
+          <p:cNvPr id="10" name="TextBox 9"/>
+          <p:cNvSpPr txBox="1"/>
+          <p:nvPr/>
+        </p:nvSpPr>
+        <p:spPr>
+          <a:xfrm>
+            <a:off x="9619488" y="1088136"/>
+            <a:ext cx="2112264" cy="256032"/>
+          </a:xfrm>
+          <a:prstGeom prst="rect">
+            <a:avLst/>
+          </a:prstGeom>
+          <a:noFill/>
+        </p:spPr>
+        <p:txBody>
+          <a:bodyPr wrap="square">
+            <a:spAutoFit/>
+          </a:bodyPr>
+          <a:lstStyle/>
+          <a:p>
+            <a:pPr algn="ctr"/>
+            <a:r>
+              <a:rPr sz="1100" b="1" i="0">
+                <a:solidFill>
+                  <a:srgbClr val="FFFFFF"/>
+                </a:solidFill>
+              </a:rPr>
+              <a:t>✅  COMPLETE</a:t>
+            </a:r>
+          </a:p>
+        </p:txBody>
+      </p:sp>
+      <p:sp>
+        <p:nvSpPr>
+          <p:cNvPr id="11" name="TextBox 10"/>
+          <p:cNvSpPr txBox="1"/>
+          <p:nvPr/>
+        </p:nvSpPr>
+        <p:spPr>
+          <a:xfrm>
+            <a:off x="457200" y="1536192"/>
+            <a:ext cx="11338560" cy="292608"/>
+          </a:xfrm>
+          <a:prstGeom prst="rect">
+            <a:avLst/>
+          </a:prstGeom>
+          <a:noFill/>
+        </p:spPr>
+        <p:txBody>
+          <a:bodyPr wrap="square">
+            <a:spAutoFit/>
+          </a:bodyPr>
+          <a:lstStyle/>
+          <a:p>
+            <a:pPr algn="l"/>
+            <a:r>
+              <a:rPr sz="1100" b="0" i="1">
+                <a:solidFill>
                   <a:srgbClr val="1A375E"/>
                 </a:solidFill>
               </a:rPr>
-              <a:t>Genetic Perturbagen Screen Results</a:t>
-            </a:r>
-          </a:p>
-        </p:txBody>
-      </p:sp>
-      <p:sp>
-        <p:nvSpPr>
-          <p:cNvPr id="8" name="Rectangle 7"/>
+              <a:t>Gene perturbagens tested at 40 ng/well in MCF7 cells (12K/well seeding density)</a:t>
+            </a:r>
+          </a:p>
+        </p:txBody>
+      </p:sp>
+      <p:sp>
+        <p:nvSpPr>
+          <p:cNvPr id="12" name="TextBox 11"/>
+          <p:cNvSpPr txBox="1"/>
+          <p:nvPr/>
+        </p:nvSpPr>
+        <p:spPr>
+          <a:xfrm>
+            <a:off x="457200" y="1883664"/>
+            <a:ext cx="7772400" cy="1600200"/>
+          </a:xfrm>
+          <a:prstGeom prst="rect">
+            <a:avLst/>
+          </a:prstGeom>
+          <a:noFill/>
+        </p:spPr>
+        <p:txBody>
+          <a:bodyPr wrap="square">
+            <a:spAutoFit/>
+          </a:bodyPr>
+          <a:lstStyle/>
+          <a:p>
+            <a:pPr>
+              <a:spcBef>
+                <a:spcPts val="400"/>
+              </a:spcBef>
+            </a:pPr>
+            <a:r>
+              <a:rPr sz="1100">
+                <a:solidFill>
+                  <a:srgbClr val="1A1A1A"/>
+                </a:solidFill>
+              </a:rPr>
+              <a:t>•  Multiple siRNA/shRNA constructs screened in a single endpoint confluency assay</a:t>
+            </a:r>
+          </a:p>
+          <a:p>
+            <a:pPr>
+              <a:spcBef>
+                <a:spcPts val="400"/>
+              </a:spcBef>
+            </a:pPr>
+            <a:r>
+              <a:rPr sz="1100">
+                <a:solidFill>
+                  <a:srgbClr val="1A1A1A"/>
+                </a:solidFill>
+              </a:rPr>
+              <a:t>•  Normalised confluency (%) reported per perturbagen relative to non-targeting control (set to 100%)</a:t>
+            </a:r>
+          </a:p>
+          <a:p>
+            <a:pPr>
+              <a:spcBef>
+                <a:spcPts val="400"/>
+              </a:spcBef>
+            </a:pPr>
+            <a:r>
+              <a:rPr sz="1100">
+                <a:solidFill>
+                  <a:srgbClr val="1A1A1A"/>
+                </a:solidFill>
+              </a:rPr>
+              <a:t>•  Values above 100% indicate enhanced growth; below 100% indicate growth inhibition</a:t>
+            </a:r>
+          </a:p>
+          <a:p>
+            <a:pPr>
+              <a:spcBef>
+                <a:spcPts val="400"/>
+              </a:spcBef>
+            </a:pPr>
+            <a:r>
+              <a:rPr sz="1100">
+                <a:solidFill>
+                  <a:srgbClr val="1A1A1A"/>
+                </a:solidFill>
+              </a:rPr>
+              <a:t>•  Single-timepoint readout — captures cumulative effect but not kinetics</a:t>
+            </a:r>
+          </a:p>
+          <a:p>
+            <a:pPr>
+              <a:spcBef>
+                <a:spcPts val="400"/>
+              </a:spcBef>
+            </a:pPr>
+            <a:r>
+              <a:rPr sz="1100">
+                <a:solidFill>
+                  <a:srgbClr val="1A1A1A"/>
+                </a:solidFill>
+              </a:rPr>
+              <a:t>•  Identifies candidate genes whose knockdown significantly alters cell proliferation</a:t>
+            </a:r>
+          </a:p>
+        </p:txBody>
+      </p:sp>
+      <p:sp>
+        <p:nvSpPr>
+          <p:cNvPr id="13" name="Rectangle 12"/>
           <p:cNvSpPr/>
           <p:nvPr/>
         </p:nvSpPr>
         <p:spPr>
           <a:xfrm>
-            <a:off x="411480" y="1389888"/>
-            <a:ext cx="5257800" cy="1664208"/>
+            <a:off x="8412480" y="1856232"/>
+            <a:ext cx="3337560" cy="1664208"/>
           </a:xfrm>
           <a:prstGeom prst="rect">
             <a:avLst/>
@@ -9777,14 +10030,127 @@
       </p:sp>
       <p:sp>
         <p:nvSpPr>
-          <p:cNvPr id="9" name="Rectangle 8"/>
+          <p:cNvPr id="14" name="TextBox 13"/>
+          <p:cNvSpPr txBox="1"/>
+          <p:nvPr/>
+        </p:nvSpPr>
+        <p:spPr>
+          <a:xfrm>
+            <a:off x="8549640" y="1901952"/>
+            <a:ext cx="3108960" cy="256032"/>
+          </a:xfrm>
+          <a:prstGeom prst="rect">
+            <a:avLst/>
+          </a:prstGeom>
+          <a:noFill/>
+        </p:spPr>
+        <p:txBody>
+          <a:bodyPr wrap="square">
+            <a:spAutoFit/>
+          </a:bodyPr>
+          <a:lstStyle/>
+          <a:p>
+            <a:pPr algn="l"/>
+            <a:r>
+              <a:rPr sz="1000" b="1" i="0">
+                <a:solidFill>
+                  <a:srgbClr val="2E75B6"/>
+                </a:solidFill>
+              </a:rPr>
+              <a:t>Interpretation</a:t>
+            </a:r>
+          </a:p>
+        </p:txBody>
+      </p:sp>
+      <p:sp>
+        <p:nvSpPr>
+          <p:cNvPr id="15" name="TextBox 14"/>
+          <p:cNvSpPr txBox="1"/>
+          <p:nvPr/>
+        </p:nvSpPr>
+        <p:spPr>
+          <a:xfrm>
+            <a:off x="8549640" y="2194560"/>
+            <a:ext cx="3108960" cy="1261872"/>
+          </a:xfrm>
+          <a:prstGeom prst="rect">
+            <a:avLst/>
+          </a:prstGeom>
+          <a:noFill/>
+        </p:spPr>
+        <p:txBody>
+          <a:bodyPr wrap="square">
+            <a:spAutoFit/>
+          </a:bodyPr>
+          <a:lstStyle/>
+          <a:p>
+            <a:pPr algn="l"/>
+            <a:r>
+              <a:rPr sz="1000" b="0" i="1">
+                <a:solidFill>
+                  <a:srgbClr val="1A1A1A"/>
+                </a:solidFill>
+              </a:rPr>
+              <a:t>A straightforward binary screen: each perturbagen either hits or misses a growth phenotype. Genes showing strong deviation from 100% are prioritised for follow-up validation.</a:t>
+            </a:r>
+          </a:p>
+        </p:txBody>
+      </p:sp>
+      <p:sp>
+        <p:nvSpPr>
+          <p:cNvPr id="16" name="Rectangle 15"/>
           <p:cNvSpPr/>
           <p:nvPr/>
         </p:nvSpPr>
         <p:spPr>
           <a:xfrm>
-            <a:off x="411480" y="1389888"/>
-            <a:ext cx="5257800" cy="347472"/>
+            <a:off x="274320" y="3840480"/>
+            <a:ext cx="11640312" cy="2633472"/>
+          </a:xfrm>
+          <a:prstGeom prst="rect">
+            <a:avLst/>
+          </a:prstGeom>
+          <a:solidFill>
+            <a:srgbClr val="F5F9FF"/>
+          </a:solidFill>
+          <a:ln w="12700">
+            <a:solidFill>
+              <a:srgbClr val="2E75B6"/>
+            </a:solidFill>
+          </a:ln>
+        </p:spPr>
+        <p:style>
+          <a:lnRef idx="1">
+            <a:schemeClr val="accent1"/>
+          </a:lnRef>
+          <a:fillRef idx="3">
+            <a:schemeClr val="accent1"/>
+          </a:fillRef>
+          <a:effectRef idx="2">
+            <a:schemeClr val="accent1"/>
+          </a:effectRef>
+          <a:fontRef idx="minor">
+            <a:schemeClr val="lt1"/>
+          </a:fontRef>
+        </p:style>
+        <p:txBody>
+          <a:bodyPr rtlCol="0" anchor="ctr"/>
+          <a:lstStyle/>
+          <a:p>
+            <a:pPr algn="ctr"/>
+          </a:p>
+        </p:txBody>
+      </p:sp>
+      <p:sp>
+        <p:nvSpPr>
+          <p:cNvPr id="17" name="Rectangle 16"/>
+          <p:cNvSpPr/>
+          <p:nvPr/>
+        </p:nvSpPr>
+        <p:spPr>
+          <a:xfrm>
+            <a:off x="274320" y="3840480"/>
+            <a:ext cx="11640312" cy="475488"/>
           </a:xfrm>
           <a:prstGeom prst="rect">
             <a:avLst/>
@@ -9820,14 +10186,14 @@
       </p:sp>
       <p:sp>
         <p:nvSpPr>
-          <p:cNvPr id="10" name="TextBox 9"/>
-          <p:cNvSpPr txBox="1"/>
-          <p:nvPr/>
-        </p:nvSpPr>
-        <p:spPr>
-          <a:xfrm>
-            <a:off x="548640" y="1435608"/>
-            <a:ext cx="3931920" cy="274320"/>
+          <p:cNvPr id="18" name="TextBox 17"/>
+          <p:cNvSpPr txBox="1"/>
+          <p:nvPr/>
+        </p:nvSpPr>
+        <p:spPr>
+          <a:xfrm>
+            <a:off x="457200" y="3913632"/>
+            <a:ext cx="8686800" cy="329184"/>
           </a:xfrm>
           <a:prstGeom prst="rect">
             <a:avLst/>
@@ -9842,26 +10208,26 @@
           <a:p>
             <a:pPr algn="l"/>
             <a:r>
-              <a:rPr sz="1200" b="1" i="0">
+              <a:rPr sz="1400" b="1" i="0">
                 <a:solidFill>
                   <a:srgbClr val="FFFFFF"/>
                 </a:solidFill>
               </a:rPr>
-              <a:t>1 Time Point  |  1 Control  (48 h)</a:t>
-            </a:r>
-          </a:p>
-        </p:txBody>
-      </p:sp>
-      <p:sp>
-        <p:nvSpPr>
-          <p:cNvPr id="11" name="Rectangle 10"/>
+              <a:t>Several Time Points  |  Multiple Controls  (23 time points, 3 h intervals, ~69 h total)</a:t>
+            </a:r>
+          </a:p>
+        </p:txBody>
+      </p:sp>
+      <p:sp>
+        <p:nvSpPr>
+          <p:cNvPr id="19" name="Rectangle 18"/>
           <p:cNvSpPr/>
           <p:nvPr/>
         </p:nvSpPr>
         <p:spPr>
           <a:xfrm>
-            <a:off x="4160520" y="1435608"/>
-            <a:ext cx="1371600" cy="256032"/>
+            <a:off x="9601200" y="3931920"/>
+            <a:ext cx="2148840" cy="292608"/>
           </a:xfrm>
           <a:prstGeom prst="rect">
             <a:avLst/>
@@ -9897,14 +10263,14 @@
       </p:sp>
       <p:sp>
         <p:nvSpPr>
-          <p:cNvPr id="12" name="TextBox 11"/>
-          <p:cNvSpPr txBox="1"/>
-          <p:nvPr/>
-        </p:nvSpPr>
-        <p:spPr>
-          <a:xfrm>
-            <a:off x="4178808" y="1444752"/>
-            <a:ext cx="1335024" cy="219456"/>
+          <p:cNvPr id="20" name="TextBox 19"/>
+          <p:cNvSpPr txBox="1"/>
+          <p:nvPr/>
+        </p:nvSpPr>
+        <p:spPr>
+          <a:xfrm>
+            <a:off x="9619488" y="3941064"/>
+            <a:ext cx="2112264" cy="256032"/>
           </a:xfrm>
           <a:prstGeom prst="rect">
             <a:avLst/>
@@ -9919,7 +10285,7 @@
           <a:p>
             <a:pPr algn="ctr"/>
             <a:r>
-              <a:rPr sz="900" b="1" i="0">
+              <a:rPr sz="1100" b="1" i="0">
                 <a:solidFill>
                   <a:srgbClr val="FFFFFF"/>
                 </a:solidFill>
@@ -9931,14 +10297,48 @@
       </p:sp>
       <p:sp>
         <p:nvSpPr>
-          <p:cNvPr id="13" name="TextBox 12"/>
-          <p:cNvSpPr txBox="1"/>
-          <p:nvPr/>
-        </p:nvSpPr>
-        <p:spPr>
-          <a:xfrm>
-            <a:off x="548640" y="1801368"/>
-            <a:ext cx="4983480" cy="1188720"/>
+          <p:cNvPr id="21" name="TextBox 20"/>
+          <p:cNvSpPr txBox="1"/>
+          <p:nvPr/>
+        </p:nvSpPr>
+        <p:spPr>
+          <a:xfrm>
+            <a:off x="457200" y="4389120"/>
+            <a:ext cx="11338560" cy="292608"/>
+          </a:xfrm>
+          <a:prstGeom prst="rect">
+            <a:avLst/>
+          </a:prstGeom>
+          <a:noFill/>
+        </p:spPr>
+        <p:txBody>
+          <a:bodyPr wrap="square">
+            <a:spAutoFit/>
+          </a:bodyPr>
+          <a:lstStyle/>
+          <a:p>
+            <a:pPr algn="l"/>
+            <a:r>
+              <a:rPr sz="1100" b="0" i="1">
+                <a:solidFill>
+                  <a:srgbClr val="1A375E"/>
+                </a:solidFill>
+              </a:rPr>
+              <a:t>Same perturbagens measured across time, enabling growth kinetics and rate calculations</a:t>
+            </a:r>
+          </a:p>
+        </p:txBody>
+      </p:sp>
+      <p:sp>
+        <p:nvSpPr>
+          <p:cNvPr id="22" name="TextBox 21"/>
+          <p:cNvSpPr txBox="1"/>
+          <p:nvPr/>
+        </p:nvSpPr>
+        <p:spPr>
+          <a:xfrm>
+            <a:off x="457200" y="4736592"/>
+            <a:ext cx="7772400" cy="1600200"/>
           </a:xfrm>
           <a:prstGeom prst="rect">
             <a:avLst/>
@@ -9957,12 +10357,12 @@
               </a:spcBef>
             </a:pPr>
             <a:r>
-              <a:rPr sz="1000">
+              <a:rPr sz="1100">
                 <a:solidFill>
                   <a:srgbClr val="1A1A1A"/>
                 </a:solidFill>
               </a:rPr>
-              <a:t>•  Multiple gene perturbagens tested at 40 ng/well</a:t>
+              <a:t>•  Growth rate computed at each time point as a ratio to the matched control group</a:t>
             </a:r>
           </a:p>
           <a:p>
@@ -9972,12 +10372,12 @@
               </a:spcBef>
             </a:pPr>
             <a:r>
-              <a:rPr sz="1000">
+              <a:rPr sz="1100">
                 <a:solidFill>
                   <a:srgbClr val="1A1A1A"/>
                 </a:solidFill>
               </a:rPr>
-              <a:t>•  Normalised confluency reported relative to non-targeting control</a:t>
+              <a:t>•  Growth rate &gt; 1.0 — cells proliferating faster than control (possible tumour suppressor knockdown)</a:t>
             </a:r>
           </a:p>
           <a:p>
@@ -9987,12 +10387,12 @@
               </a:spcBef>
             </a:pPr>
             <a:r>
-              <a:rPr sz="1000">
+              <a:rPr sz="1100">
                 <a:solidFill>
                   <a:srgbClr val="1A1A1A"/>
                 </a:solidFill>
               </a:rPr>
-              <a:t>•  Identifies knockdowns that inhibit or enhance cell growth</a:t>
+              <a:t>•  Growth rate &lt; 1.0 — cells proliferating slower than control (growth-promoting gene silenced)</a:t>
             </a:r>
           </a:p>
           <a:p>
@@ -10002,26 +10402,41 @@
               </a:spcBef>
             </a:pPr>
             <a:r>
-              <a:rPr sz="1000">
+              <a:rPr sz="1100">
                 <a:solidFill>
                   <a:srgbClr val="1A1A1A"/>
                 </a:solidFill>
               </a:rPr>
-              <a:t>•  Binary readout — no dose-response fitting applied</a:t>
-            </a:r>
-          </a:p>
-        </p:txBody>
-      </p:sp>
-      <p:sp>
-        <p:nvSpPr>
-          <p:cNvPr id="14" name="Rectangle 13"/>
+              <a:t>•  Multiple independent control groups enable robust plate-wide normalisation</a:t>
+            </a:r>
+          </a:p>
+          <a:p>
+            <a:pPr>
+              <a:spcBef>
+                <a:spcPts val="400"/>
+              </a:spcBef>
+            </a:pPr>
+            <a:r>
+              <a:rPr sz="1100">
+                <a:solidFill>
+                  <a:srgbClr val="1A1A1A"/>
+                </a:solidFill>
+              </a:rPr>
+              <a:t>•  Time-resolved data reveals whether effects are immediate, delayed, or transient</a:t>
+            </a:r>
+          </a:p>
+        </p:txBody>
+      </p:sp>
+      <p:sp>
+        <p:nvSpPr>
+          <p:cNvPr id="23" name="Rectangle 22"/>
           <p:cNvSpPr/>
           <p:nvPr/>
         </p:nvSpPr>
         <p:spPr>
           <a:xfrm>
-            <a:off x="411480" y="3200400"/>
-            <a:ext cx="5257800" cy="1664208"/>
+            <a:off x="8412480" y="4709160"/>
+            <a:ext cx="3337560" cy="1664208"/>
           </a:xfrm>
           <a:prstGeom prst="rect">
             <a:avLst/>
@@ -10059,14 +10474,344 @@
       </p:sp>
       <p:sp>
         <p:nvSpPr>
-          <p:cNvPr id="15" name="Rectangle 14"/>
+          <p:cNvPr id="24" name="TextBox 23"/>
+          <p:cNvSpPr txBox="1"/>
+          <p:nvPr/>
+        </p:nvSpPr>
+        <p:spPr>
+          <a:xfrm>
+            <a:off x="8549640" y="4754880"/>
+            <a:ext cx="3108960" cy="256032"/>
+          </a:xfrm>
+          <a:prstGeom prst="rect">
+            <a:avLst/>
+          </a:prstGeom>
+          <a:noFill/>
+        </p:spPr>
+        <p:txBody>
+          <a:bodyPr wrap="square">
+            <a:spAutoFit/>
+          </a:bodyPr>
+          <a:lstStyle/>
+          <a:p>
+            <a:pPr algn="l"/>
+            <a:r>
+              <a:rPr sz="1000" b="1" i="0">
+                <a:solidFill>
+                  <a:srgbClr val="2E75B6"/>
+                </a:solidFill>
+              </a:rPr>
+              <a:t>Interpretation</a:t>
+            </a:r>
+          </a:p>
+        </p:txBody>
+      </p:sp>
+      <p:sp>
+        <p:nvSpPr>
+          <p:cNvPr id="25" name="TextBox 24"/>
+          <p:cNvSpPr txBox="1"/>
+          <p:nvPr/>
+        </p:nvSpPr>
+        <p:spPr>
+          <a:xfrm>
+            <a:off x="8549640" y="5047488"/>
+            <a:ext cx="3108960" cy="1261872"/>
+          </a:xfrm>
+          <a:prstGeom prst="rect">
+            <a:avLst/>
+          </a:prstGeom>
+          <a:noFill/>
+        </p:spPr>
+        <p:txBody>
+          <a:bodyPr wrap="square">
+            <a:spAutoFit/>
+          </a:bodyPr>
+          <a:lstStyle/>
+          <a:p>
+            <a:pPr algn="l"/>
+            <a:r>
+              <a:rPr sz="1000" b="0" i="1">
+                <a:solidFill>
+                  <a:srgbClr val="1A1A1A"/>
+                </a:solidFill>
+              </a:rPr>
+              <a:t>Time-course data provides richer biological insight than endpoint alone — a perturbagen with a delayed growth rate change may reflect an indirect or adaptive cellular response.</a:t>
+            </a:r>
+          </a:p>
+        </p:txBody>
+      </p:sp>
+      <p:sp>
+        <p:nvSpPr>
+          <p:cNvPr id="26" name="Rectangle 25"/>
           <p:cNvSpPr/>
           <p:nvPr/>
         </p:nvSpPr>
         <p:spPr>
           <a:xfrm>
-            <a:off x="411480" y="3200400"/>
-            <a:ext cx="5257800" cy="347472"/>
+            <a:off x="274320" y="6473952"/>
+            <a:ext cx="11640312" cy="0"/>
+          </a:xfrm>
+          <a:prstGeom prst="rect">
+            <a:avLst/>
+          </a:prstGeom>
+          <a:noFill/>
+          <a:ln>
+            <a:noFill/>
+          </a:ln>
+        </p:spPr>
+        <p:style>
+          <a:lnRef idx="1">
+            <a:schemeClr val="accent1"/>
+          </a:lnRef>
+          <a:fillRef idx="3">
+            <a:schemeClr val="accent1"/>
+          </a:fillRef>
+          <a:effectRef idx="2">
+            <a:schemeClr val="accent1"/>
+          </a:effectRef>
+          <a:fontRef idx="minor">
+            <a:schemeClr val="lt1"/>
+          </a:fontRef>
+        </p:style>
+        <p:txBody>
+          <a:bodyPr rtlCol="0" anchor="ctr"/>
+          <a:lstStyle/>
+          <a:p>
+            <a:pPr algn="ctr"/>
+          </a:p>
+        </p:txBody>
+      </p:sp>
+      <p:sp>
+        <p:nvSpPr>
+          <p:cNvPr id="27" name="Rectangle 26"/>
+          <p:cNvSpPr/>
+          <p:nvPr/>
+        </p:nvSpPr>
+        <p:spPr>
+          <a:xfrm>
+            <a:off x="274320" y="6473952"/>
+            <a:ext cx="6400800" cy="0"/>
+          </a:xfrm>
+          <a:prstGeom prst="rect">
+            <a:avLst/>
+          </a:prstGeom>
+          <a:noFill/>
+          <a:ln>
+            <a:noFill/>
+          </a:ln>
+        </p:spPr>
+        <p:style>
+          <a:lnRef idx="1">
+            <a:schemeClr val="accent1"/>
+          </a:lnRef>
+          <a:fillRef idx="3">
+            <a:schemeClr val="accent1"/>
+          </a:fillRef>
+          <a:effectRef idx="2">
+            <a:schemeClr val="accent1"/>
+          </a:effectRef>
+          <a:fontRef idx="minor">
+            <a:schemeClr val="lt1"/>
+          </a:fontRef>
+        </p:style>
+        <p:txBody>
+          <a:bodyPr rtlCol="0" anchor="ctr"/>
+          <a:lstStyle/>
+          <a:p>
+            <a:pPr algn="ctr"/>
+          </a:p>
+        </p:txBody>
+      </p:sp>
+      <p:sp>
+        <p:nvSpPr>
+          <p:cNvPr id="28" name="Rectangle 27"/>
+          <p:cNvSpPr/>
+          <p:nvPr/>
+        </p:nvSpPr>
+        <p:spPr>
+          <a:xfrm>
+            <a:off x="0" y="6656832"/>
+            <a:ext cx="12188952" cy="201168"/>
+          </a:xfrm>
+          <a:prstGeom prst="rect">
+            <a:avLst/>
+          </a:prstGeom>
+          <a:solidFill>
+            <a:srgbClr val="1A375E"/>
+          </a:solidFill>
+          <a:ln>
+            <a:noFill/>
+          </a:ln>
+        </p:spPr>
+        <p:style>
+          <a:lnRef idx="1">
+            <a:schemeClr val="accent1"/>
+          </a:lnRef>
+          <a:fillRef idx="3">
+            <a:schemeClr val="accent1"/>
+          </a:fillRef>
+          <a:effectRef idx="2">
+            <a:schemeClr val="accent1"/>
+          </a:effectRef>
+          <a:fontRef idx="minor">
+            <a:schemeClr val="lt1"/>
+          </a:fontRef>
+        </p:style>
+        <p:txBody>
+          <a:bodyPr rtlCol="0" anchor="ctr"/>
+          <a:lstStyle/>
+          <a:p>
+            <a:pPr algn="ctr"/>
+          </a:p>
+        </p:txBody>
+      </p:sp>
+      <p:sp>
+        <p:nvSpPr>
+          <p:cNvPr id="29" name="TextBox 28"/>
+          <p:cNvSpPr txBox="1"/>
+          <p:nvPr/>
+        </p:nvSpPr>
+        <p:spPr>
+          <a:xfrm>
+            <a:off x="10515600" y="6675120"/>
+            <a:ext cx="1554480" cy="182880"/>
+          </a:xfrm>
+          <a:prstGeom prst="rect">
+            <a:avLst/>
+          </a:prstGeom>
+          <a:noFill/>
+        </p:spPr>
+        <p:txBody>
+          <a:bodyPr wrap="square">
+            <a:spAutoFit/>
+          </a:bodyPr>
+          <a:lstStyle/>
+          <a:p>
+            <a:pPr algn="r"/>
+            <a:r>
+              <a:rPr sz="900" b="0" i="0">
+                <a:solidFill>
+                  <a:srgbClr val="FFFFFF"/>
+                </a:solidFill>
+              </a:rPr>
+              <a:t>Slide 5 of 6</a:t>
+            </a:r>
+          </a:p>
+        </p:txBody>
+      </p:sp>
+      <p:sp>
+        <p:nvSpPr>
+          <p:cNvPr id="30" name="TextBox 29"/>
+          <p:cNvSpPr txBox="1"/>
+          <p:nvPr/>
+        </p:nvSpPr>
+        <p:spPr>
+          <a:xfrm>
+            <a:off x="228600" y="6675120"/>
+            <a:ext cx="9144000" cy="182880"/>
+          </a:xfrm>
+          <a:prstGeom prst="rect">
+            <a:avLst/>
+          </a:prstGeom>
+          <a:noFill/>
+        </p:spPr>
+        <p:txBody>
+          <a:bodyPr wrap="square">
+            <a:spAutoFit/>
+          </a:bodyPr>
+          <a:lstStyle/>
+          <a:p>
+            <a:pPr algn="l"/>
+            <a:r>
+              <a:rPr sz="900" b="0" i="0">
+                <a:solidFill>
+                  <a:srgbClr val="BDD7EE"/>
+                </a:solidFill>
+              </a:rPr>
+              <a:t>HTSplotter  |  Nunes et al., PLoS One 2024  |  DOI: 10.1371/journal.pone.0296322</a:t>
+            </a:r>
+          </a:p>
+        </p:txBody>
+      </p:sp>
+    </p:spTree>
+  </p:cSld>
+  <p:clrMapOvr>
+    <a:masterClrMapping/>
+  </p:clrMapOvr>
+</p:sld>
+</file>
+
+<file path=ppt/slides/slide6.xml><?xml version="1.0" encoding="utf-8"?>
+<p:sld xmlns:a="http://schemas.openxmlformats.org/drawingml/2006/main" xmlns:p="http://schemas.openxmlformats.org/presentationml/2006/main" xmlns:r="http://schemas.openxmlformats.org/officeDocument/2006/relationships">
+  <p:cSld>
+    <p:bg>
+      <p:bgPr>
+        <a:solidFill>
+          <a:srgbClr val="FFFFFF"/>
+        </a:solidFill>
+        <a:effectLst/>
+      </p:bgPr>
+    </p:bg>
+    <p:spTree>
+      <p:nvGrpSpPr>
+        <p:cNvPr id="1" name=""/>
+        <p:cNvGrpSpPr/>
+        <p:nvPr/>
+      </p:nvGrpSpPr>
+      <p:grpSpPr/>
+      <p:sp>
+        <p:nvSpPr>
+          <p:cNvPr id="2" name="Rectangle 1"/>
+          <p:cNvSpPr/>
+          <p:nvPr/>
+        </p:nvSpPr>
+        <p:spPr>
+          <a:xfrm>
+            <a:off x="0" y="0"/>
+            <a:ext cx="12188952" cy="804672"/>
+          </a:xfrm>
+          <a:prstGeom prst="rect">
+            <a:avLst/>
+          </a:prstGeom>
+          <a:solidFill>
+            <a:srgbClr val="1A375E"/>
+          </a:solidFill>
+          <a:ln>
+            <a:noFill/>
+          </a:ln>
+        </p:spPr>
+        <p:style>
+          <a:lnRef idx="1">
+            <a:schemeClr val="accent1"/>
+          </a:lnRef>
+          <a:fillRef idx="3">
+            <a:schemeClr val="accent1"/>
+          </a:fillRef>
+          <a:effectRef idx="2">
+            <a:schemeClr val="accent1"/>
+          </a:effectRef>
+          <a:fontRef idx="minor">
+            <a:schemeClr val="lt1"/>
+          </a:fontRef>
+        </p:style>
+        <p:txBody>
+          <a:bodyPr rtlCol="0" anchor="ctr"/>
+          <a:lstStyle/>
+          <a:p>
+            <a:pPr algn="ctr"/>
+          </a:p>
+        </p:txBody>
+      </p:sp>
+      <p:sp>
+        <p:nvSpPr>
+          <p:cNvPr id="3" name="Rectangle 2"/>
+          <p:cNvSpPr/>
+          <p:nvPr/>
+        </p:nvSpPr>
+        <p:spPr>
+          <a:xfrm>
+            <a:off x="0" y="0"/>
+            <a:ext cx="73152" cy="804672"/>
           </a:xfrm>
           <a:prstGeom prst="rect">
             <a:avLst/>
@@ -10102,14 +10847,14 @@
       </p:sp>
       <p:sp>
         <p:nvSpPr>
-          <p:cNvPr id="16" name="TextBox 15"/>
-          <p:cNvSpPr txBox="1"/>
-          <p:nvPr/>
-        </p:nvSpPr>
-        <p:spPr>
-          <a:xfrm>
-            <a:off x="548640" y="3246120"/>
-            <a:ext cx="3931920" cy="274320"/>
+          <p:cNvPr id="4" name="TextBox 3"/>
+          <p:cNvSpPr txBox="1"/>
+          <p:nvPr/>
+        </p:nvSpPr>
+        <p:spPr>
+          <a:xfrm>
+            <a:off x="228600" y="91440"/>
+            <a:ext cx="11704320" cy="502920"/>
           </a:xfrm>
           <a:prstGeom prst="rect">
             <a:avLst/>
@@ -10124,35 +10869,71 @@
           <a:p>
             <a:pPr algn="l"/>
             <a:r>
-              <a:rPr sz="1200" b="1" i="0">
+              <a:rPr sz="2600" b="1" i="0">
                 <a:solidFill>
                   <a:srgbClr val="FFFFFF"/>
                 </a:solidFill>
               </a:rPr>
-              <a:t>Several Time Points  |  Multiple Controls  (23 TP, 3 h interval)</a:t>
-            </a:r>
-          </a:p>
-        </p:txBody>
-      </p:sp>
-      <p:sp>
-        <p:nvSpPr>
-          <p:cNvPr id="17" name="Rectangle 16"/>
+              <a:t>AI-Assisted Results Interpretation</a:t>
+            </a:r>
+          </a:p>
+        </p:txBody>
+      </p:sp>
+      <p:sp>
+        <p:nvSpPr>
+          <p:cNvPr id="5" name="TextBox 4"/>
+          <p:cNvSpPr txBox="1"/>
+          <p:nvPr/>
+        </p:nvSpPr>
+        <p:spPr>
+          <a:xfrm>
+            <a:off x="228600" y="548640"/>
+            <a:ext cx="11704320" cy="228600"/>
+          </a:xfrm>
+          <a:prstGeom prst="rect">
+            <a:avLst/>
+          </a:prstGeom>
+          <a:noFill/>
+        </p:spPr>
+        <p:txBody>
+          <a:bodyPr wrap="square">
+            <a:spAutoFit/>
+          </a:bodyPr>
+          <a:lstStyle/>
+          <a:p>
+            <a:pPr algn="l"/>
+            <a:r>
+              <a:rPr sz="1200" b="0" i="0">
+                <a:solidFill>
+                  <a:srgbClr val="BDD7EE"/>
+                </a:solidFill>
+              </a:rPr>
+              <a:t>Interactive Claude-powered chat interface built on top of HTSplotter</a:t>
+            </a:r>
+          </a:p>
+        </p:txBody>
+      </p:sp>
+      <p:sp>
+        <p:nvSpPr>
+          <p:cNvPr id="6" name="Rectangle 5"/>
           <p:cNvSpPr/>
           <p:nvPr/>
         </p:nvSpPr>
         <p:spPr>
           <a:xfrm>
-            <a:off x="4160520" y="3246120"/>
-            <a:ext cx="1371600" cy="256032"/>
+            <a:off x="274320" y="914400"/>
+            <a:ext cx="11640312" cy="658368"/>
           </a:xfrm>
           <a:prstGeom prst="rect">
             <a:avLst/>
           </a:prstGeom>
           <a:solidFill>
-            <a:srgbClr val="1F8678"/>
+            <a:srgbClr val="EFF4FB"/>
           </a:solidFill>
-          <a:ln>
-            <a:noFill/>
+          <a:ln w="12700">
+            <a:solidFill>
+              <a:srgbClr val="2E75B6"/>
+            </a:solidFill>
           </a:ln>
         </p:spPr>
         <p:style>
@@ -10179,141 +10960,58 @@
       </p:sp>
       <p:sp>
         <p:nvSpPr>
-          <p:cNvPr id="18" name="TextBox 17"/>
-          <p:cNvSpPr txBox="1"/>
-          <p:nvPr/>
-        </p:nvSpPr>
-        <p:spPr>
-          <a:xfrm>
-            <a:off x="4178808" y="3255264"/>
-            <a:ext cx="1335024" cy="219456"/>
-          </a:xfrm>
-          <a:prstGeom prst="rect">
-            <a:avLst/>
-          </a:prstGeom>
-          <a:noFill/>
-        </p:spPr>
-        <p:txBody>
-          <a:bodyPr wrap="square">
-            <a:spAutoFit/>
-          </a:bodyPr>
-          <a:lstStyle/>
-          <a:p>
-            <a:pPr algn="ctr"/>
-            <a:r>
-              <a:rPr sz="900" b="1" i="0">
-                <a:solidFill>
-                  <a:srgbClr val="FFFFFF"/>
-                </a:solidFill>
-              </a:rPr>
-              <a:t>✅  COMPLETE</a:t>
-            </a:r>
-          </a:p>
-        </p:txBody>
-      </p:sp>
-      <p:sp>
-        <p:nvSpPr>
-          <p:cNvPr id="19" name="TextBox 18"/>
-          <p:cNvSpPr txBox="1"/>
-          <p:nvPr/>
-        </p:nvSpPr>
-        <p:spPr>
-          <a:xfrm>
-            <a:off x="548640" y="3611880"/>
-            <a:ext cx="4983480" cy="1188720"/>
-          </a:xfrm>
-          <a:prstGeom prst="rect">
-            <a:avLst/>
-          </a:prstGeom>
-          <a:noFill/>
-        </p:spPr>
-        <p:txBody>
-          <a:bodyPr wrap="square">
-            <a:spAutoFit/>
-          </a:bodyPr>
-          <a:lstStyle/>
-          <a:p>
-            <a:pPr>
-              <a:spcBef>
-                <a:spcPts val="400"/>
-              </a:spcBef>
-            </a:pPr>
-            <a:r>
-              <a:rPr sz="1000">
-                <a:solidFill>
-                  <a:srgbClr val="1A1A1A"/>
-                </a:solidFill>
-              </a:rPr>
-              <a:t>•  Growth rate computed at every time point for each perturbagen</a:t>
-            </a:r>
-          </a:p>
-          <a:p>
-            <a:pPr>
-              <a:spcBef>
-                <a:spcPts val="400"/>
-              </a:spcBef>
-            </a:pPr>
-            <a:r>
-              <a:rPr sz="1000">
-                <a:solidFill>
-                  <a:srgbClr val="1A1A1A"/>
-                </a:solidFill>
-              </a:rPr>
-              <a:t>•  Growth rate ratio &gt; 1.0 = faster than control (possible growth suppressor released)</a:t>
-            </a:r>
-          </a:p>
-          <a:p>
-            <a:pPr>
-              <a:spcBef>
-                <a:spcPts val="400"/>
-              </a:spcBef>
-            </a:pPr>
-            <a:r>
-              <a:rPr sz="1000">
-                <a:solidFill>
-                  <a:srgbClr val="1A1A1A"/>
-                </a:solidFill>
-              </a:rPr>
-              <a:t>•  Growth rate ratio &lt; 1.0 = slower than control (growth inhibition)</a:t>
-            </a:r>
-          </a:p>
-          <a:p>
-            <a:pPr>
-              <a:spcBef>
-                <a:spcPts val="400"/>
-              </a:spcBef>
-            </a:pPr>
-            <a:r>
-              <a:rPr sz="1000">
-                <a:solidFill>
-                  <a:srgbClr val="1A1A1A"/>
-                </a:solidFill>
-              </a:rPr>
-              <a:t>•  Multiple control groups allow robust normalisation across the plate</a:t>
-            </a:r>
-          </a:p>
-        </p:txBody>
-      </p:sp>
-      <p:sp>
-        <p:nvSpPr>
-          <p:cNvPr id="20" name="Rectangle 19"/>
+          <p:cNvPr id="7" name="TextBox 6"/>
+          <p:cNvSpPr txBox="1"/>
+          <p:nvPr/>
+        </p:nvSpPr>
+        <p:spPr>
+          <a:xfrm>
+            <a:off x="457200" y="978408"/>
+            <a:ext cx="11247120" cy="530352"/>
+          </a:xfrm>
+          <a:prstGeom prst="rect">
+            <a:avLst/>
+          </a:prstGeom>
+          <a:noFill/>
+        </p:spPr>
+        <p:txBody>
+          <a:bodyPr wrap="square">
+            <a:spAutoFit/>
+          </a:bodyPr>
+          <a:lstStyle/>
+          <a:p>
+            <a:pPr algn="l"/>
+            <a:r>
+              <a:rPr sz="1200" b="0" i="0">
+                <a:solidFill>
+                  <a:srgbClr val="1A375E"/>
+                </a:solidFill>
+              </a:rPr>
+              <a:t>After running any HTSplotter analysis, researchers can ask plain-English questions about their results using an AI chat interface powered by the Anthropic Claude API (claude-opus-4-7). No bioinformatics expertise required — just type your question.</a:t>
+            </a:r>
+          </a:p>
+        </p:txBody>
+      </p:sp>
+      <p:sp>
+        <p:nvSpPr>
+          <p:cNvPr id="8" name="Rectangle 7"/>
           <p:cNvSpPr/>
           <p:nvPr/>
         </p:nvSpPr>
         <p:spPr>
           <a:xfrm>
-            <a:off x="411480" y="4919472"/>
-            <a:ext cx="5257800" cy="1298448"/>
+            <a:off x="274320" y="1664208"/>
+            <a:ext cx="5394960" cy="4782312"/>
           </a:xfrm>
           <a:prstGeom prst="rect">
             <a:avLst/>
           </a:prstGeom>
           <a:solidFill>
-            <a:srgbClr val="FFF8E1"/>
+            <a:srgbClr val="F5F9FF"/>
           </a:solidFill>
           <a:ln w="12700">
             <a:solidFill>
-              <a:srgbClr val="C55A11"/>
+              <a:srgbClr val="2E75B6"/>
             </a:solidFill>
           </a:ln>
         </p:spPr>
@@ -10341,14 +11039,449 @@
       </p:sp>
       <p:sp>
         <p:nvSpPr>
+          <p:cNvPr id="9" name="TextBox 8"/>
+          <p:cNvSpPr txBox="1"/>
+          <p:nvPr/>
+        </p:nvSpPr>
+        <p:spPr>
+          <a:xfrm>
+            <a:off x="457200" y="1737360"/>
+            <a:ext cx="5029200" cy="347472"/>
+          </a:xfrm>
+          <a:prstGeom prst="rect">
+            <a:avLst/>
+          </a:prstGeom>
+          <a:noFill/>
+        </p:spPr>
+        <p:txBody>
+          <a:bodyPr wrap="square">
+            <a:spAutoFit/>
+          </a:bodyPr>
+          <a:lstStyle/>
+          <a:p>
+            <a:pPr algn="l"/>
+            <a:r>
+              <a:rPr sz="1500" b="1" i="0">
+                <a:solidFill>
+                  <a:srgbClr val="1A375E"/>
+                </a:solidFill>
+              </a:rPr>
+              <a:t>How It Works</a:t>
+            </a:r>
+          </a:p>
+        </p:txBody>
+      </p:sp>
+      <p:sp>
+        <p:nvSpPr>
+          <p:cNvPr id="10" name="Rectangle 9"/>
+          <p:cNvSpPr/>
+          <p:nvPr/>
+        </p:nvSpPr>
+        <p:spPr>
+          <a:xfrm>
+            <a:off x="384048" y="2176272"/>
+            <a:ext cx="475488" cy="475488"/>
+          </a:xfrm>
+          <a:prstGeom prst="rect">
+            <a:avLst/>
+          </a:prstGeom>
+          <a:solidFill>
+            <a:srgbClr val="2E75B6"/>
+          </a:solidFill>
+          <a:ln>
+            <a:noFill/>
+          </a:ln>
+        </p:spPr>
+        <p:style>
+          <a:lnRef idx="1">
+            <a:schemeClr val="accent1"/>
+          </a:lnRef>
+          <a:fillRef idx="3">
+            <a:schemeClr val="accent1"/>
+          </a:fillRef>
+          <a:effectRef idx="2">
+            <a:schemeClr val="accent1"/>
+          </a:effectRef>
+          <a:fontRef idx="minor">
+            <a:schemeClr val="lt1"/>
+          </a:fontRef>
+        </p:style>
+        <p:txBody>
+          <a:bodyPr rtlCol="0" anchor="ctr"/>
+          <a:lstStyle/>
+          <a:p>
+            <a:pPr algn="ctr"/>
+          </a:p>
+        </p:txBody>
+      </p:sp>
+      <p:sp>
+        <p:nvSpPr>
+          <p:cNvPr id="11" name="TextBox 10"/>
+          <p:cNvSpPr txBox="1"/>
+          <p:nvPr/>
+        </p:nvSpPr>
+        <p:spPr>
+          <a:xfrm>
+            <a:off x="402336" y="2249424"/>
+            <a:ext cx="438912" cy="329184"/>
+          </a:xfrm>
+          <a:prstGeom prst="rect">
+            <a:avLst/>
+          </a:prstGeom>
+          <a:noFill/>
+        </p:spPr>
+        <p:txBody>
+          <a:bodyPr wrap="square">
+            <a:spAutoFit/>
+          </a:bodyPr>
+          <a:lstStyle/>
+          <a:p>
+            <a:pPr algn="ctr"/>
+            <a:r>
+              <a:rPr sz="1600" b="1" i="0">
+                <a:solidFill>
+                  <a:srgbClr val="FFFFFF"/>
+                </a:solidFill>
+              </a:rPr>
+              <a:t>1</a:t>
+            </a:r>
+          </a:p>
+        </p:txBody>
+      </p:sp>
+      <p:sp>
+        <p:nvSpPr>
+          <p:cNvPr id="12" name="TextBox 11"/>
+          <p:cNvSpPr txBox="1"/>
+          <p:nvPr/>
+        </p:nvSpPr>
+        <p:spPr>
+          <a:xfrm>
+            <a:off x="960120" y="2194560"/>
+            <a:ext cx="4526280" cy="237744"/>
+          </a:xfrm>
+          <a:prstGeom prst="rect">
+            <a:avLst/>
+          </a:prstGeom>
+          <a:noFill/>
+        </p:spPr>
+        <p:txBody>
+          <a:bodyPr wrap="square">
+            <a:spAutoFit/>
+          </a:bodyPr>
+          <a:lstStyle/>
+          <a:p>
+            <a:pPr algn="l"/>
+            <a:r>
+              <a:rPr sz="1100" b="1" i="0">
+                <a:solidFill>
+                  <a:srgbClr val="1A375E"/>
+                </a:solidFill>
+              </a:rPr>
+              <a:t>Run HTSplotter</a:t>
+            </a:r>
+          </a:p>
+        </p:txBody>
+      </p:sp>
+      <p:sp>
+        <p:nvSpPr>
+          <p:cNvPr id="13" name="TextBox 12"/>
+          <p:cNvSpPr txBox="1"/>
+          <p:nvPr/>
+        </p:nvSpPr>
+        <p:spPr>
+          <a:xfrm>
+            <a:off x="960120" y="2423160"/>
+            <a:ext cx="4526280" cy="548640"/>
+          </a:xfrm>
+          <a:prstGeom prst="rect">
+            <a:avLst/>
+          </a:prstGeom>
+          <a:noFill/>
+        </p:spPr>
+        <p:txBody>
+          <a:bodyPr wrap="square">
+            <a:spAutoFit/>
+          </a:bodyPr>
+          <a:lstStyle/>
+          <a:p>
+            <a:pPr algn="l"/>
+            <a:r>
+              <a:rPr sz="1000" b="0" i="0">
+                <a:solidFill>
+                  <a:srgbClr val="1A1A1A"/>
+                </a:solidFill>
+              </a:rPr>
+              <a:t>Execute any analysis (drug screen, combination, genetic). Results are saved as .txt files in the output_results/ folder.</a:t>
+            </a:r>
+          </a:p>
+        </p:txBody>
+      </p:sp>
+      <p:sp>
+        <p:nvSpPr>
+          <p:cNvPr id="14" name="Rectangle 13"/>
+          <p:cNvSpPr/>
+          <p:nvPr/>
+        </p:nvSpPr>
+        <p:spPr>
+          <a:xfrm>
+            <a:off x="384048" y="3026664"/>
+            <a:ext cx="475488" cy="475488"/>
+          </a:xfrm>
+          <a:prstGeom prst="rect">
+            <a:avLst/>
+          </a:prstGeom>
+          <a:solidFill>
+            <a:srgbClr val="2E75B6"/>
+          </a:solidFill>
+          <a:ln>
+            <a:noFill/>
+          </a:ln>
+        </p:spPr>
+        <p:style>
+          <a:lnRef idx="1">
+            <a:schemeClr val="accent1"/>
+          </a:lnRef>
+          <a:fillRef idx="3">
+            <a:schemeClr val="accent1"/>
+          </a:fillRef>
+          <a:effectRef idx="2">
+            <a:schemeClr val="accent1"/>
+          </a:effectRef>
+          <a:fontRef idx="minor">
+            <a:schemeClr val="lt1"/>
+          </a:fontRef>
+        </p:style>
+        <p:txBody>
+          <a:bodyPr rtlCol="0" anchor="ctr"/>
+          <a:lstStyle/>
+          <a:p>
+            <a:pPr algn="ctr"/>
+          </a:p>
+        </p:txBody>
+      </p:sp>
+      <p:sp>
+        <p:nvSpPr>
+          <p:cNvPr id="15" name="TextBox 14"/>
+          <p:cNvSpPr txBox="1"/>
+          <p:nvPr/>
+        </p:nvSpPr>
+        <p:spPr>
+          <a:xfrm>
+            <a:off x="402336" y="3099816"/>
+            <a:ext cx="438912" cy="329184"/>
+          </a:xfrm>
+          <a:prstGeom prst="rect">
+            <a:avLst/>
+          </a:prstGeom>
+          <a:noFill/>
+        </p:spPr>
+        <p:txBody>
+          <a:bodyPr wrap="square">
+            <a:spAutoFit/>
+          </a:bodyPr>
+          <a:lstStyle/>
+          <a:p>
+            <a:pPr algn="ctr"/>
+            <a:r>
+              <a:rPr sz="1600" b="1" i="0">
+                <a:solidFill>
+                  <a:srgbClr val="FFFFFF"/>
+                </a:solidFill>
+              </a:rPr>
+              <a:t>2</a:t>
+            </a:r>
+          </a:p>
+        </p:txBody>
+      </p:sp>
+      <p:sp>
+        <p:nvSpPr>
+          <p:cNvPr id="16" name="TextBox 15"/>
+          <p:cNvSpPr txBox="1"/>
+          <p:nvPr/>
+        </p:nvSpPr>
+        <p:spPr>
+          <a:xfrm>
+            <a:off x="960120" y="3044952"/>
+            <a:ext cx="4526280" cy="237744"/>
+          </a:xfrm>
+          <a:prstGeom prst="rect">
+            <a:avLst/>
+          </a:prstGeom>
+          <a:noFill/>
+        </p:spPr>
+        <p:txBody>
+          <a:bodyPr wrap="square">
+            <a:spAutoFit/>
+          </a:bodyPr>
+          <a:lstStyle/>
+          <a:p>
+            <a:pPr algn="l"/>
+            <a:r>
+              <a:rPr sz="1100" b="1" i="0">
+                <a:solidFill>
+                  <a:srgbClr val="1A375E"/>
+                </a:solidFill>
+              </a:rPr>
+              <a:t>Set your API key</a:t>
+            </a:r>
+          </a:p>
+        </p:txBody>
+      </p:sp>
+      <p:sp>
+        <p:nvSpPr>
+          <p:cNvPr id="17" name="TextBox 16"/>
+          <p:cNvSpPr txBox="1"/>
+          <p:nvPr/>
+        </p:nvSpPr>
+        <p:spPr>
+          <a:xfrm>
+            <a:off x="960120" y="3273552"/>
+            <a:ext cx="4526280" cy="548640"/>
+          </a:xfrm>
+          <a:prstGeom prst="rect">
+            <a:avLst/>
+          </a:prstGeom>
+          <a:noFill/>
+        </p:spPr>
+        <p:txBody>
+          <a:bodyPr wrap="square">
+            <a:spAutoFit/>
+          </a:bodyPr>
+          <a:lstStyle/>
+          <a:p>
+            <a:pPr algn="l"/>
+            <a:r>
+              <a:rPr sz="1000" b="0" i="0">
+                <a:solidFill>
+                  <a:srgbClr val="1A1A1A"/>
+                </a:solidFill>
+              </a:rPr>
+              <a:t>Get a free API key from console.anthropic.com. Set it once: export ANTHROPIC_API_KEY='sk-ant-...'</a:t>
+            </a:r>
+          </a:p>
+        </p:txBody>
+      </p:sp>
+      <p:sp>
+        <p:nvSpPr>
+          <p:cNvPr id="18" name="Rectangle 17"/>
+          <p:cNvSpPr/>
+          <p:nvPr/>
+        </p:nvSpPr>
+        <p:spPr>
+          <a:xfrm>
+            <a:off x="384048" y="3877056"/>
+            <a:ext cx="475488" cy="475488"/>
+          </a:xfrm>
+          <a:prstGeom prst="rect">
+            <a:avLst/>
+          </a:prstGeom>
+          <a:solidFill>
+            <a:srgbClr val="2E75B6"/>
+          </a:solidFill>
+          <a:ln>
+            <a:noFill/>
+          </a:ln>
+        </p:spPr>
+        <p:style>
+          <a:lnRef idx="1">
+            <a:schemeClr val="accent1"/>
+          </a:lnRef>
+          <a:fillRef idx="3">
+            <a:schemeClr val="accent1"/>
+          </a:fillRef>
+          <a:effectRef idx="2">
+            <a:schemeClr val="accent1"/>
+          </a:effectRef>
+          <a:fontRef idx="minor">
+            <a:schemeClr val="lt1"/>
+          </a:fontRef>
+        </p:style>
+        <p:txBody>
+          <a:bodyPr rtlCol="0" anchor="ctr"/>
+          <a:lstStyle/>
+          <a:p>
+            <a:pPr algn="ctr"/>
+          </a:p>
+        </p:txBody>
+      </p:sp>
+      <p:sp>
+        <p:nvSpPr>
+          <p:cNvPr id="19" name="TextBox 18"/>
+          <p:cNvSpPr txBox="1"/>
+          <p:nvPr/>
+        </p:nvSpPr>
+        <p:spPr>
+          <a:xfrm>
+            <a:off x="402336" y="3950208"/>
+            <a:ext cx="438912" cy="329184"/>
+          </a:xfrm>
+          <a:prstGeom prst="rect">
+            <a:avLst/>
+          </a:prstGeom>
+          <a:noFill/>
+        </p:spPr>
+        <p:txBody>
+          <a:bodyPr wrap="square">
+            <a:spAutoFit/>
+          </a:bodyPr>
+          <a:lstStyle/>
+          <a:p>
+            <a:pPr algn="ctr"/>
+            <a:r>
+              <a:rPr sz="1600" b="1" i="0">
+                <a:solidFill>
+                  <a:srgbClr val="FFFFFF"/>
+                </a:solidFill>
+              </a:rPr>
+              <a:t>3</a:t>
+            </a:r>
+          </a:p>
+        </p:txBody>
+      </p:sp>
+      <p:sp>
+        <p:nvSpPr>
+          <p:cNvPr id="20" name="TextBox 19"/>
+          <p:cNvSpPr txBox="1"/>
+          <p:nvPr/>
+        </p:nvSpPr>
+        <p:spPr>
+          <a:xfrm>
+            <a:off x="960120" y="3895344"/>
+            <a:ext cx="4526280" cy="237744"/>
+          </a:xfrm>
+          <a:prstGeom prst="rect">
+            <a:avLst/>
+          </a:prstGeom>
+          <a:noFill/>
+        </p:spPr>
+        <p:txBody>
+          <a:bodyPr wrap="square">
+            <a:spAutoFit/>
+          </a:bodyPr>
+          <a:lstStyle/>
+          <a:p>
+            <a:pPr algn="l"/>
+            <a:r>
+              <a:rPr sz="1100" b="1" i="0">
+                <a:solidFill>
+                  <a:srgbClr val="1A375E"/>
+                </a:solidFill>
+              </a:rPr>
+              <a:t>Launch the chat</a:t>
+            </a:r>
+          </a:p>
+        </p:txBody>
+      </p:sp>
+      <p:sp>
+        <p:nvSpPr>
           <p:cNvPr id="21" name="TextBox 20"/>
           <p:cNvSpPr txBox="1"/>
           <p:nvPr/>
         </p:nvSpPr>
         <p:spPr>
           <a:xfrm>
-            <a:off x="548640" y="4974336"/>
-            <a:ext cx="4937760" cy="274320"/>
+            <a:off x="960120" y="4123944"/>
+            <a:ext cx="4526280" cy="548640"/>
           </a:xfrm>
           <a:prstGeom prst="rect">
             <a:avLst/>
@@ -10363,26 +11496,104 @@
           <a:p>
             <a:pPr algn="l"/>
             <a:r>
-              <a:rPr sz="1200" b="1" i="0">
-                <a:solidFill>
-                  <a:srgbClr val="C55A11"/>
-                </a:solidFill>
-              </a:rPr>
-              <a:t>⚠  Genetic-Chemical Perturbagen</a:t>
-            </a:r>
-          </a:p>
-        </p:txBody>
-      </p:sp>
-      <p:sp>
-        <p:nvSpPr>
-          <p:cNvPr id="22" name="TextBox 21"/>
-          <p:cNvSpPr txBox="1"/>
-          <p:nvPr/>
-        </p:nvSpPr>
-        <p:spPr>
-          <a:xfrm>
-            <a:off x="548640" y="5285232"/>
-            <a:ext cx="5029200" cy="914400"/>
+              <a:rPr sz="1000" b="0" i="0">
+                <a:solidFill>
+                  <a:srgbClr val="1A1A1A"/>
+                </a:solidFill>
+              </a:rPr>
+              <a:t>Run:  python chat_results.py  [results_dir]
+The script loads all result files automatically and caches them for efficiency.</a:t>
+            </a:r>
+          </a:p>
+        </p:txBody>
+      </p:sp>
+      <p:sp>
+        <p:nvSpPr>
+          <p:cNvPr id="22" name="Rectangle 21"/>
+          <p:cNvSpPr/>
+          <p:nvPr/>
+        </p:nvSpPr>
+        <p:spPr>
+          <a:xfrm>
+            <a:off x="384048" y="4727448"/>
+            <a:ext cx="475488" cy="475488"/>
+          </a:xfrm>
+          <a:prstGeom prst="rect">
+            <a:avLst/>
+          </a:prstGeom>
+          <a:solidFill>
+            <a:srgbClr val="2E75B6"/>
+          </a:solidFill>
+          <a:ln>
+            <a:noFill/>
+          </a:ln>
+        </p:spPr>
+        <p:style>
+          <a:lnRef idx="1">
+            <a:schemeClr val="accent1"/>
+          </a:lnRef>
+          <a:fillRef idx="3">
+            <a:schemeClr val="accent1"/>
+          </a:fillRef>
+          <a:effectRef idx="2">
+            <a:schemeClr val="accent1"/>
+          </a:effectRef>
+          <a:fontRef idx="minor">
+            <a:schemeClr val="lt1"/>
+          </a:fontRef>
+        </p:style>
+        <p:txBody>
+          <a:bodyPr rtlCol="0" anchor="ctr"/>
+          <a:lstStyle/>
+          <a:p>
+            <a:pPr algn="ctr"/>
+          </a:p>
+        </p:txBody>
+      </p:sp>
+      <p:sp>
+        <p:nvSpPr>
+          <p:cNvPr id="23" name="TextBox 22"/>
+          <p:cNvSpPr txBox="1"/>
+          <p:nvPr/>
+        </p:nvSpPr>
+        <p:spPr>
+          <a:xfrm>
+            <a:off x="402336" y="4800600"/>
+            <a:ext cx="438912" cy="329184"/>
+          </a:xfrm>
+          <a:prstGeom prst="rect">
+            <a:avLst/>
+          </a:prstGeom>
+          <a:noFill/>
+        </p:spPr>
+        <p:txBody>
+          <a:bodyPr wrap="square">
+            <a:spAutoFit/>
+          </a:bodyPr>
+          <a:lstStyle/>
+          <a:p>
+            <a:pPr algn="ctr"/>
+            <a:r>
+              <a:rPr sz="1600" b="1" i="0">
+                <a:solidFill>
+                  <a:srgbClr val="FFFFFF"/>
+                </a:solidFill>
+              </a:rPr>
+              <a:t>4</a:t>
+            </a:r>
+          </a:p>
+        </p:txBody>
+      </p:sp>
+      <p:sp>
+        <p:nvSpPr>
+          <p:cNvPr id="24" name="TextBox 23"/>
+          <p:cNvSpPr txBox="1"/>
+          <p:nvPr/>
+        </p:nvSpPr>
+        <p:spPr>
+          <a:xfrm>
+            <a:off x="960120" y="4745736"/>
+            <a:ext cx="4526280" cy="237744"/>
           </a:xfrm>
           <a:prstGeom prst="rect">
             <a:avLst/>
@@ -10397,26 +11608,205 @@
           <a:p>
             <a:pPr algn="l"/>
             <a:r>
+              <a:rPr sz="1100" b="1" i="0">
+                <a:solidFill>
+                  <a:srgbClr val="1A375E"/>
+                </a:solidFill>
+              </a:rPr>
+              <a:t>Ask questions</a:t>
+            </a:r>
+          </a:p>
+        </p:txBody>
+      </p:sp>
+      <p:sp>
+        <p:nvSpPr>
+          <p:cNvPr id="25" name="TextBox 24"/>
+          <p:cNvSpPr txBox="1"/>
+          <p:nvPr/>
+        </p:nvSpPr>
+        <p:spPr>
+          <a:xfrm>
+            <a:off x="960120" y="4974336"/>
+            <a:ext cx="4526280" cy="548640"/>
+          </a:xfrm>
+          <a:prstGeom prst="rect">
+            <a:avLst/>
+          </a:prstGeom>
+          <a:noFill/>
+        </p:spPr>
+        <p:txBody>
+          <a:bodyPr wrap="square">
+            <a:spAutoFit/>
+          </a:bodyPr>
+          <a:lstStyle/>
+          <a:p>
+            <a:pPr algn="l"/>
+            <a:r>
               <a:rPr sz="1000" b="0" i="0">
                 <a:solidFill>
                   <a:srgbClr val="1A1A1A"/>
                 </a:solidFill>
               </a:rPr>
-              <a:t>Combines gene knockdown with drug treatment. HTSplotter supports this experiment type, but the example datasets encountered a known array-dimension mismatch in the installed version. All other three experiment types ran successfully.</a:t>
-            </a:r>
-          </a:p>
-        </p:txBody>
-      </p:sp>
-      <p:sp>
-        <p:nvSpPr>
-          <p:cNvPr id="23" name="Rectangle 22"/>
+              <a:t>Type any question about your data. The chat maintains conversation history so you can ask follow-ups.</a:t>
+            </a:r>
+          </a:p>
+        </p:txBody>
+      </p:sp>
+      <p:sp>
+        <p:nvSpPr>
+          <p:cNvPr id="26" name="Rectangle 25"/>
           <p:cNvSpPr/>
           <p:nvPr/>
         </p:nvSpPr>
         <p:spPr>
           <a:xfrm>
-            <a:off x="6172200" y="914400"/>
-            <a:ext cx="5715000" cy="5532120"/>
+            <a:off x="384048" y="5577840"/>
+            <a:ext cx="475488" cy="475488"/>
+          </a:xfrm>
+          <a:prstGeom prst="rect">
+            <a:avLst/>
+          </a:prstGeom>
+          <a:solidFill>
+            <a:srgbClr val="2E75B6"/>
+          </a:solidFill>
+          <a:ln>
+            <a:noFill/>
+          </a:ln>
+        </p:spPr>
+        <p:style>
+          <a:lnRef idx="1">
+            <a:schemeClr val="accent1"/>
+          </a:lnRef>
+          <a:fillRef idx="3">
+            <a:schemeClr val="accent1"/>
+          </a:fillRef>
+          <a:effectRef idx="2">
+            <a:schemeClr val="accent1"/>
+          </a:effectRef>
+          <a:fontRef idx="minor">
+            <a:schemeClr val="lt1"/>
+          </a:fontRef>
+        </p:style>
+        <p:txBody>
+          <a:bodyPr rtlCol="0" anchor="ctr"/>
+          <a:lstStyle/>
+          <a:p>
+            <a:pPr algn="ctr"/>
+          </a:p>
+        </p:txBody>
+      </p:sp>
+      <p:sp>
+        <p:nvSpPr>
+          <p:cNvPr id="27" name="TextBox 26"/>
+          <p:cNvSpPr txBox="1"/>
+          <p:nvPr/>
+        </p:nvSpPr>
+        <p:spPr>
+          <a:xfrm>
+            <a:off x="402336" y="5650992"/>
+            <a:ext cx="438912" cy="329184"/>
+          </a:xfrm>
+          <a:prstGeom prst="rect">
+            <a:avLst/>
+          </a:prstGeom>
+          <a:noFill/>
+        </p:spPr>
+        <p:txBody>
+          <a:bodyPr wrap="square">
+            <a:spAutoFit/>
+          </a:bodyPr>
+          <a:lstStyle/>
+          <a:p>
+            <a:pPr algn="ctr"/>
+            <a:r>
+              <a:rPr sz="1600" b="1" i="0">
+                <a:solidFill>
+                  <a:srgbClr val="FFFFFF"/>
+                </a:solidFill>
+              </a:rPr>
+              <a:t>5</a:t>
+            </a:r>
+          </a:p>
+        </p:txBody>
+      </p:sp>
+      <p:sp>
+        <p:nvSpPr>
+          <p:cNvPr id="28" name="TextBox 27"/>
+          <p:cNvSpPr txBox="1"/>
+          <p:nvPr/>
+        </p:nvSpPr>
+        <p:spPr>
+          <a:xfrm>
+            <a:off x="960120" y="5596127"/>
+            <a:ext cx="4526280" cy="237744"/>
+          </a:xfrm>
+          <a:prstGeom prst="rect">
+            <a:avLst/>
+          </a:prstGeom>
+          <a:noFill/>
+        </p:spPr>
+        <p:txBody>
+          <a:bodyPr wrap="square">
+            <a:spAutoFit/>
+          </a:bodyPr>
+          <a:lstStyle/>
+          <a:p>
+            <a:pPr algn="l"/>
+            <a:r>
+              <a:rPr sz="1100" b="1" i="0">
+                <a:solidFill>
+                  <a:srgbClr val="1A375E"/>
+                </a:solidFill>
+              </a:rPr>
+              <a:t>Exit anytime</a:t>
+            </a:r>
+          </a:p>
+        </p:txBody>
+      </p:sp>
+      <p:sp>
+        <p:nvSpPr>
+          <p:cNvPr id="29" name="TextBox 28"/>
+          <p:cNvSpPr txBox="1"/>
+          <p:nvPr/>
+        </p:nvSpPr>
+        <p:spPr>
+          <a:xfrm>
+            <a:off x="960120" y="5824727"/>
+            <a:ext cx="4526280" cy="548640"/>
+          </a:xfrm>
+          <a:prstGeom prst="rect">
+            <a:avLst/>
+          </a:prstGeom>
+          <a:noFill/>
+        </p:spPr>
+        <p:txBody>
+          <a:bodyPr wrap="square">
+            <a:spAutoFit/>
+          </a:bodyPr>
+          <a:lstStyle/>
+          <a:p>
+            <a:pPr algn="l"/>
+            <a:r>
+              <a:rPr sz="1000" b="0" i="0">
+                <a:solidFill>
+                  <a:srgbClr val="1A1A1A"/>
+                </a:solidFill>
+              </a:rPr>
+              <a:t>Type quit, exit, or press Ctrl+C to stop.</a:t>
+            </a:r>
+          </a:p>
+        </p:txBody>
+      </p:sp>
+      <p:sp>
+        <p:nvSpPr>
+          <p:cNvPr id="30" name="Rectangle 29"/>
+          <p:cNvSpPr/>
+          <p:nvPr/>
+        </p:nvSpPr>
+        <p:spPr>
+          <a:xfrm>
+            <a:off x="5943600" y="1664208"/>
+            <a:ext cx="5971032" cy="4782312"/>
           </a:xfrm>
           <a:prstGeom prst="rect">
             <a:avLst/>
@@ -10454,14 +11844,14 @@
       </p:sp>
       <p:sp>
         <p:nvSpPr>
-          <p:cNvPr id="24" name="TextBox 23"/>
-          <p:cNvSpPr txBox="1"/>
-          <p:nvPr/>
-        </p:nvSpPr>
-        <p:spPr>
-          <a:xfrm>
-            <a:off x="6327648" y="978408"/>
-            <a:ext cx="5376672" cy="347472"/>
+          <p:cNvPr id="31" name="TextBox 30"/>
+          <p:cNvSpPr txBox="1"/>
+          <p:nvPr/>
+        </p:nvSpPr>
+        <p:spPr>
+          <a:xfrm>
+            <a:off x="6126480" y="1737360"/>
+            <a:ext cx="5577840" cy="347472"/>
           </a:xfrm>
           <a:prstGeom prst="rect">
             <a:avLst/>
@@ -10476,60 +11866,26 @@
           <a:p>
             <a:pPr algn="l"/>
             <a:r>
-              <a:rPr sz="1400" b="1" i="0">
+              <a:rPr sz="1500" b="1" i="0">
                 <a:solidFill>
                   <a:srgbClr val="1A375E"/>
                 </a:solidFill>
               </a:rPr>
-              <a:t>🤖  AI-Assisted Results Chat</a:t>
-            </a:r>
-          </a:p>
-        </p:txBody>
-      </p:sp>
-      <p:sp>
-        <p:nvSpPr>
-          <p:cNvPr id="25" name="TextBox 24"/>
-          <p:cNvSpPr txBox="1"/>
-          <p:nvPr/>
-        </p:nvSpPr>
-        <p:spPr>
-          <a:xfrm>
-            <a:off x="6327648" y="1389888"/>
-            <a:ext cx="5376672" cy="658368"/>
-          </a:xfrm>
-          <a:prstGeom prst="rect">
-            <a:avLst/>
-          </a:prstGeom>
-          <a:noFill/>
-        </p:spPr>
-        <p:txBody>
-          <a:bodyPr wrap="square">
-            <a:spAutoFit/>
-          </a:bodyPr>
-          <a:lstStyle/>
-          <a:p>
-            <a:pPr algn="l"/>
-            <a:r>
-              <a:rPr sz="1100" b="0" i="0">
-                <a:solidFill>
-                  <a:srgbClr val="1A1A1A"/>
-                </a:solidFill>
-              </a:rPr>
-              <a:t>An interactive chat interface built on top of HTSplotter using the Anthropic Claude API. Load any results folder and ask plain-English questions — no bioinformatics expertise required.</a:t>
-            </a:r>
-          </a:p>
-        </p:txBody>
-      </p:sp>
-      <p:sp>
-        <p:nvSpPr>
-          <p:cNvPr id="26" name="Rectangle 25"/>
+              <a:t>Example Conversation</a:t>
+            </a:r>
+          </a:p>
+        </p:txBody>
+      </p:sp>
+      <p:sp>
+        <p:nvSpPr>
+          <p:cNvPr id="32" name="Rectangle 31"/>
           <p:cNvSpPr/>
           <p:nvPr/>
         </p:nvSpPr>
         <p:spPr>
           <a:xfrm>
-            <a:off x="6400800" y="2148840"/>
-            <a:ext cx="5257800" cy="457200"/>
+            <a:off x="6035040" y="2194560"/>
+            <a:ext cx="5577840" cy="457200"/>
           </a:xfrm>
           <a:prstGeom prst="rect">
             <a:avLst/>
@@ -10567,14 +11923,14 @@
       </p:sp>
       <p:sp>
         <p:nvSpPr>
-          <p:cNvPr id="27" name="TextBox 26"/>
-          <p:cNvSpPr txBox="1"/>
-          <p:nvPr/>
-        </p:nvSpPr>
-        <p:spPr>
-          <a:xfrm>
-            <a:off x="6492240" y="2203704"/>
-            <a:ext cx="5120640" cy="365760"/>
+          <p:cNvPr id="33" name="TextBox 32"/>
+          <p:cNvSpPr txBox="1"/>
+          <p:nvPr/>
+        </p:nvSpPr>
+        <p:spPr>
+          <a:xfrm>
+            <a:off x="6144768" y="2249424"/>
+            <a:ext cx="5413248" cy="365760"/>
           </a:xfrm>
           <a:prstGeom prst="rect">
             <a:avLst/>
@@ -10601,14 +11957,14 @@
       </p:sp>
       <p:sp>
         <p:nvSpPr>
-          <p:cNvPr id="28" name="Rectangle 27"/>
+          <p:cNvPr id="34" name="Rectangle 33"/>
           <p:cNvSpPr/>
           <p:nvPr/>
         </p:nvSpPr>
         <p:spPr>
           <a:xfrm>
-            <a:off x="6400800" y="2679192"/>
-            <a:ext cx="5257800" cy="457200"/>
+            <a:off x="6035040" y="2743200"/>
+            <a:ext cx="5577840" cy="457200"/>
           </a:xfrm>
           <a:prstGeom prst="rect">
             <a:avLst/>
@@ -10646,14 +12002,14 @@
       </p:sp>
       <p:sp>
         <p:nvSpPr>
-          <p:cNvPr id="29" name="TextBox 28"/>
-          <p:cNvSpPr txBox="1"/>
-          <p:nvPr/>
-        </p:nvSpPr>
-        <p:spPr>
-          <a:xfrm>
-            <a:off x="6492240" y="2734056"/>
-            <a:ext cx="5120640" cy="365760"/>
+          <p:cNvPr id="35" name="TextBox 34"/>
+          <p:cNvSpPr txBox="1"/>
+          <p:nvPr/>
+        </p:nvSpPr>
+        <p:spPr>
+          <a:xfrm>
+            <a:off x="6144768" y="2798064"/>
+            <a:ext cx="5413248" cy="365760"/>
           </a:xfrm>
           <a:prstGeom prst="rect">
             <a:avLst/>
@@ -10673,21 +12029,21 @@
                   <a:srgbClr val="1A1A1A"/>
                 </a:solidFill>
               </a:rPr>
-              <a:t>Claude:  Prexasertib — IC₅₀ ≈ 10 nM, ~66× more potent than MK-1775.</a:t>
-            </a:r>
-          </a:p>
-        </p:txBody>
-      </p:sp>
-      <p:sp>
-        <p:nvSpPr>
-          <p:cNvPr id="30" name="Rectangle 29"/>
+              <a:t>Claude:  Prexasertib — IC₅₀ ≈ 10 nM. That's ~27× more potent than BAY1895344 and ~66× more potent than MK-1775 in MCF7 cells.</a:t>
+            </a:r>
+          </a:p>
+        </p:txBody>
+      </p:sp>
+      <p:sp>
+        <p:nvSpPr>
+          <p:cNvPr id="36" name="Rectangle 35"/>
           <p:cNvSpPr/>
           <p:nvPr/>
         </p:nvSpPr>
         <p:spPr>
           <a:xfrm>
-            <a:off x="6400800" y="3209544"/>
-            <a:ext cx="5257800" cy="457200"/>
+            <a:off x="6035040" y="3291840"/>
+            <a:ext cx="5577840" cy="457200"/>
           </a:xfrm>
           <a:prstGeom prst="rect">
             <a:avLst/>
@@ -10725,14 +12081,14 @@
       </p:sp>
       <p:sp>
         <p:nvSpPr>
-          <p:cNvPr id="31" name="TextBox 30"/>
-          <p:cNvSpPr txBox="1"/>
-          <p:nvPr/>
-        </p:nvSpPr>
-        <p:spPr>
-          <a:xfrm>
-            <a:off x="6492240" y="3264408"/>
-            <a:ext cx="5120640" cy="365760"/>
+          <p:cNvPr id="37" name="TextBox 36"/>
+          <p:cNvSpPr txBox="1"/>
+          <p:nvPr/>
+        </p:nvSpPr>
+        <p:spPr>
+          <a:xfrm>
+            <a:off x="6144768" y="3346704"/>
+            <a:ext cx="5413248" cy="365760"/>
           </a:xfrm>
           <a:prstGeom prst="rect">
             <a:avLst/>
@@ -10759,14 +12115,14 @@
       </p:sp>
       <p:sp>
         <p:nvSpPr>
-          <p:cNvPr id="32" name="Rectangle 31"/>
+          <p:cNvPr id="38" name="Rectangle 37"/>
           <p:cNvSpPr/>
           <p:nvPr/>
         </p:nvSpPr>
         <p:spPr>
           <a:xfrm>
-            <a:off x="6400800" y="3739896"/>
-            <a:ext cx="5257800" cy="457200"/>
+            <a:off x="6035040" y="3840479"/>
+            <a:ext cx="5577840" cy="640080"/>
           </a:xfrm>
           <a:prstGeom prst="rect">
             <a:avLst/>
@@ -10804,14 +12160,14 @@
       </p:sp>
       <p:sp>
         <p:nvSpPr>
-          <p:cNvPr id="33" name="TextBox 32"/>
-          <p:cNvSpPr txBox="1"/>
-          <p:nvPr/>
-        </p:nvSpPr>
-        <p:spPr>
-          <a:xfrm>
-            <a:off x="6492240" y="3794759"/>
-            <a:ext cx="5120640" cy="365760"/>
+          <p:cNvPr id="39" name="TextBox 38"/>
+          <p:cNvSpPr txBox="1"/>
+          <p:nvPr/>
+        </p:nvSpPr>
+        <p:spPr>
+          <a:xfrm>
+            <a:off x="6144768" y="3895343"/>
+            <a:ext cx="5413248" cy="548640"/>
           </a:xfrm>
           <a:prstGeom prst="rect">
             <a:avLst/>
@@ -10831,22 +12187,21 @@
                   <a:srgbClr val="1A1A1A"/>
                 </a:solidFill>
               </a:rPr>
-              <a:t>Claude:  Yes — Bliss scores up to +0.56. Strongest at mid-range
-MK-1775 with low Prexasertib doses.</a:t>
-            </a:r>
-          </a:p>
-        </p:txBody>
-      </p:sp>
-      <p:sp>
-        <p:nvSpPr>
-          <p:cNvPr id="34" name="Rectangle 33"/>
+              <a:t>Claude:  Yes — Bliss scores reach +0.56, indicating clear synergy. The strongest effect occurs at mid-range MK-1775 (137–1,235 nM) combined with low Prexasertib doses (1.4–7.1 nM).</a:t>
+            </a:r>
+          </a:p>
+        </p:txBody>
+      </p:sp>
+      <p:sp>
+        <p:nvSpPr>
+          <p:cNvPr id="40" name="Rectangle 39"/>
           <p:cNvSpPr/>
           <p:nvPr/>
         </p:nvSpPr>
         <p:spPr>
           <a:xfrm>
-            <a:off x="6400800" y="4343400"/>
-            <a:ext cx="5257800" cy="457200"/>
+            <a:off x="6035040" y="4571999"/>
+            <a:ext cx="5577840" cy="457200"/>
           </a:xfrm>
           <a:prstGeom prst="rect">
             <a:avLst/>
@@ -10884,14 +12239,14 @@
       </p:sp>
       <p:sp>
         <p:nvSpPr>
-          <p:cNvPr id="35" name="TextBox 34"/>
-          <p:cNvSpPr txBox="1"/>
-          <p:nvPr/>
-        </p:nvSpPr>
-        <p:spPr>
-          <a:xfrm>
-            <a:off x="6492240" y="4398264"/>
-            <a:ext cx="5120640" cy="365760"/>
+          <p:cNvPr id="41" name="TextBox 40"/>
+          <p:cNvSpPr txBox="1"/>
+          <p:nvPr/>
+        </p:nvSpPr>
+        <p:spPr>
+          <a:xfrm>
+            <a:off x="6144768" y="4626863"/>
+            <a:ext cx="5413248" cy="365760"/>
           </a:xfrm>
           <a:prstGeom prst="rect">
             <a:avLst/>
@@ -10918,14 +12273,14 @@
       </p:sp>
       <p:sp>
         <p:nvSpPr>
-          <p:cNvPr id="36" name="Rectangle 35"/>
+          <p:cNvPr id="42" name="Rectangle 41"/>
           <p:cNvSpPr/>
           <p:nvPr/>
         </p:nvSpPr>
         <p:spPr>
           <a:xfrm>
-            <a:off x="6400800" y="4873752"/>
-            <a:ext cx="5257800" cy="457200"/>
+            <a:off x="6035040" y="5120639"/>
+            <a:ext cx="5577840" cy="640080"/>
           </a:xfrm>
           <a:prstGeom prst="rect">
             <a:avLst/>
@@ -10963,14 +12318,14 @@
       </p:sp>
       <p:sp>
         <p:nvSpPr>
-          <p:cNvPr id="37" name="TextBox 36"/>
-          <p:cNvSpPr txBox="1"/>
-          <p:nvPr/>
-        </p:nvSpPr>
-        <p:spPr>
-          <a:xfrm>
-            <a:off x="6492240" y="4928616"/>
-            <a:ext cx="5120640" cy="365760"/>
+          <p:cNvPr id="43" name="TextBox 42"/>
+          <p:cNvSpPr txBox="1"/>
+          <p:nvPr/>
+        </p:nvSpPr>
+        <p:spPr>
+          <a:xfrm>
+            <a:off x="6144768" y="5175503"/>
+            <a:ext cx="5413248" cy="548640"/>
           </a:xfrm>
           <a:prstGeom prst="rect">
             <a:avLst/>
@@ -10990,22 +12345,62 @@
                   <a:srgbClr val="1A1A1A"/>
                 </a:solidFill>
               </a:rPr>
-              <a:t>Claude:  The knockdown is growing faster than control — it may
-have silenced a tumour suppressor or growth brake.</a:t>
-            </a:r>
-          </a:p>
-        </p:txBody>
-      </p:sp>
-      <p:sp>
-        <p:nvSpPr>
-          <p:cNvPr id="38" name="Rectangle 37"/>
+              <a:t>Claude:  A growth rate &gt; 1 means those cells grew faster than the control. This could indicate the knockdown silenced a growth-suppressing gene, effectively releasing a brake on proliferation.</a:t>
+            </a:r>
+          </a:p>
+        </p:txBody>
+      </p:sp>
+      <p:sp>
+        <p:nvSpPr>
+          <p:cNvPr id="44" name="Rectangle 43"/>
           <p:cNvSpPr/>
           <p:nvPr/>
         </p:nvSpPr>
         <p:spPr>
           <a:xfrm>
-            <a:off x="6263640" y="5650992"/>
-            <a:ext cx="5577840" cy="566928"/>
+            <a:off x="274320" y="6473952"/>
+            <a:ext cx="11640312" cy="0"/>
+          </a:xfrm>
+          <a:prstGeom prst="rect">
+            <a:avLst/>
+          </a:prstGeom>
+          <a:noFill/>
+          <a:ln>
+            <a:noFill/>
+          </a:ln>
+        </p:spPr>
+        <p:style>
+          <a:lnRef idx="1">
+            <a:schemeClr val="accent1"/>
+          </a:lnRef>
+          <a:fillRef idx="3">
+            <a:schemeClr val="accent1"/>
+          </a:fillRef>
+          <a:effectRef idx="2">
+            <a:schemeClr val="accent1"/>
+          </a:effectRef>
+          <a:fontRef idx="minor">
+            <a:schemeClr val="lt1"/>
+          </a:fontRef>
+        </p:style>
+        <p:txBody>
+          <a:bodyPr rtlCol="0" anchor="ctr"/>
+          <a:lstStyle/>
+          <a:p>
+            <a:pPr algn="ctr"/>
+          </a:p>
+        </p:txBody>
+      </p:sp>
+      <p:sp>
+        <p:nvSpPr>
+          <p:cNvPr id="45" name="Rectangle 44"/>
+          <p:cNvSpPr/>
+          <p:nvPr/>
+        </p:nvSpPr>
+        <p:spPr>
+          <a:xfrm>
+            <a:off x="274320" y="6291072"/>
+            <a:ext cx="11640312" cy="201168"/>
           </a:xfrm>
           <a:prstGeom prst="rect">
             <a:avLst/>
@@ -11041,14 +12436,14 @@
       </p:sp>
       <p:sp>
         <p:nvSpPr>
-          <p:cNvPr id="39" name="TextBox 38"/>
-          <p:cNvSpPr txBox="1"/>
-          <p:nvPr/>
-        </p:nvSpPr>
-        <p:spPr>
-          <a:xfrm>
-            <a:off x="6400800" y="5687568"/>
-            <a:ext cx="1828800" cy="228600"/>
+          <p:cNvPr id="46" name="TextBox 45"/>
+          <p:cNvSpPr txBox="1"/>
+          <p:nvPr/>
+        </p:nvSpPr>
+        <p:spPr>
+          <a:xfrm>
+            <a:off x="365760" y="6309360"/>
+            <a:ext cx="11430000" cy="164592"/>
           </a:xfrm>
           <a:prstGeom prst="rect">
             <a:avLst/>
@@ -11063,121 +12458,19 @@
           <a:p>
             <a:pPr algn="l"/>
             <a:r>
-              <a:rPr sz="1000" b="1" i="0">
+              <a:rPr sz="900" b="1" i="0">
                 <a:solidFill>
                   <a:srgbClr val="BDD7EE"/>
                 </a:solidFill>
               </a:rPr>
-              <a:t>How to use</a:t>
-            </a:r>
-          </a:p>
-        </p:txBody>
-      </p:sp>
-      <p:sp>
-        <p:nvSpPr>
-          <p:cNvPr id="40" name="TextBox 39"/>
-          <p:cNvSpPr txBox="1"/>
-          <p:nvPr/>
-        </p:nvSpPr>
-        <p:spPr>
-          <a:xfrm>
-            <a:off x="6400800" y="5907024"/>
-            <a:ext cx="5303520" cy="201168"/>
-          </a:xfrm>
-          <a:prstGeom prst="rect">
-            <a:avLst/>
-          </a:prstGeom>
-          <a:noFill/>
-        </p:spPr>
-        <p:txBody>
-          <a:bodyPr wrap="square">
-            <a:spAutoFit/>
-          </a:bodyPr>
-          <a:lstStyle/>
-          <a:p>
-            <a:pPr algn="l"/>
-            <a:r>
-              <a:rPr sz="900" b="1" i="0">
-                <a:solidFill>
-                  <a:srgbClr val="BDD7EE"/>
-                </a:solidFill>
-              </a:rPr>
-              <a:t>export ANTHROPIC_API_KEY='sk-ant-...'</a:t>
-            </a:r>
-          </a:p>
-        </p:txBody>
-      </p:sp>
-      <p:sp>
-        <p:nvSpPr>
-          <p:cNvPr id="41" name="TextBox 40"/>
-          <p:cNvSpPr txBox="1"/>
-          <p:nvPr/>
-        </p:nvSpPr>
-        <p:spPr>
-          <a:xfrm>
-            <a:off x="6400800" y="6080760"/>
-            <a:ext cx="5303520" cy="201168"/>
-          </a:xfrm>
-          <a:prstGeom prst="rect">
-            <a:avLst/>
-          </a:prstGeom>
-          <a:noFill/>
-        </p:spPr>
-        <p:txBody>
-          <a:bodyPr wrap="square">
-            <a:spAutoFit/>
-          </a:bodyPr>
-          <a:lstStyle/>
-          <a:p>
-            <a:pPr algn="l"/>
-            <a:r>
-              <a:rPr sz="900" b="1" i="0">
-                <a:solidFill>
-                  <a:srgbClr val="BDD7EE"/>
-                </a:solidFill>
-              </a:rPr>
-              <a:t>python chat_results.py  [path/to/output_results/]</a:t>
-            </a:r>
-          </a:p>
-        </p:txBody>
-      </p:sp>
-      <p:sp>
-        <p:nvSpPr>
-          <p:cNvPr id="42" name="TextBox 41"/>
-          <p:cNvSpPr txBox="1"/>
-          <p:nvPr/>
-        </p:nvSpPr>
-        <p:spPr>
-          <a:xfrm>
-            <a:off x="8961120" y="5687568"/>
-            <a:ext cx="2651760" cy="228600"/>
-          </a:xfrm>
-          <a:prstGeom prst="rect">
-            <a:avLst/>
-          </a:prstGeom>
-          <a:noFill/>
-        </p:spPr>
-        <p:txBody>
-          <a:bodyPr wrap="square">
-            <a:spAutoFit/>
-          </a:bodyPr>
-          <a:lstStyle/>
-          <a:p>
-            <a:pPr algn="r"/>
-            <a:r>
-              <a:rPr sz="900" b="0" i="0">
-                <a:solidFill>
-                  <a:srgbClr val="88BBE0"/>
-                </a:solidFill>
-              </a:rPr>
-              <a:t>github.com/aaronwils246/HTSplotter-chat</a:t>
-            </a:r>
-          </a:p>
-        </p:txBody>
-      </p:sp>
-      <p:sp>
-        <p:nvSpPr>
-          <p:cNvPr id="43" name="Rectangle 42"/>
+              <a:t>Model: claude-opus-4-7  ·  Streaming responses  ·  Prompt caching (cost-efficient)  ·  Full conversation history  ·  Works with any HTSplotter output folder  ·  github.com/aaronwils246/HTSplotter-chat</a:t>
+            </a:r>
+          </a:p>
+        </p:txBody>
+      </p:sp>
+      <p:sp>
+        <p:nvSpPr>
+          <p:cNvPr id="47" name="Rectangle 46"/>
           <p:cNvSpPr/>
           <p:nvPr/>
         </p:nvSpPr>
@@ -11220,7 +12513,7 @@
       </p:sp>
       <p:sp>
         <p:nvSpPr>
-          <p:cNvPr id="44" name="TextBox 43"/>
+          <p:cNvPr id="48" name="TextBox 47"/>
           <p:cNvSpPr txBox="1"/>
           <p:nvPr/>
         </p:nvSpPr>
@@ -11247,14 +12540,14 @@
                   <a:srgbClr val="FFFFFF"/>
                 </a:solidFill>
               </a:rPr>
-              <a:t>Slide 5 of 5</a:t>
-            </a:r>
-          </a:p>
-        </p:txBody>
-      </p:sp>
-      <p:sp>
-        <p:nvSpPr>
-          <p:cNvPr id="45" name="TextBox 44"/>
+              <a:t>Slide 6 of 6</a:t>
+            </a:r>
+          </a:p>
+        </p:txBody>
+      </p:sp>
+      <p:sp>
+        <p:nvSpPr>
+          <p:cNvPr id="49" name="TextBox 48"/>
           <p:cNvSpPr txBox="1"/>
           <p:nvPr/>
         </p:nvSpPr>

</xml_diff>

<commit_message>
Slide 5: add gene target hits table with anonymization note
Co-Authored-By: Claude Opus 4.6 <noreply@anthropic.com>
</commit_message>
<xml_diff>
--- a/HTSplotter_Summary.pptx
+++ b/HTSplotter_Summary.pptx
@@ -9769,7 +9769,7 @@
                   <a:srgbClr val="FFFFFF"/>
                 </a:solidFill>
               </a:rPr>
-              <a:t>1 Time Point  |  1 Control  (48 h endpoint)</a:t>
+              <a:t>1 Time Point  |  1 Control  (48 h endpoint)  —  75 perturbagens screened</a:t>
             </a:r>
           </a:p>
         </p:txBody>
@@ -9860,7 +9860,7 @@
         <p:spPr>
           <a:xfrm>
             <a:off x="457200" y="1536192"/>
-            <a:ext cx="11338560" cy="292608"/>
+            <a:ext cx="11247120" cy="292608"/>
           </a:xfrm>
           <a:prstGeom prst="rect">
             <a:avLst/>
@@ -9880,7 +9880,7 @@
                   <a:srgbClr val="1A375E"/>
                 </a:solidFill>
               </a:rPr>
-              <a:t>Gene perturbagens tested at 40 ng/well in MCF7 cells (12K/well seeding density)</a:t>
+              <a:t>Gene perturbagens tested at 40 ng/well in MCF7 cells (12K/well). Normalised confluency relative to non-targeting control (100%). Note: gene names are anonymized in the HTSplotter public example dataset.</a:t>
             </a:r>
           </a:p>
         </p:txBody>
@@ -9894,7 +9894,7 @@
         <p:spPr>
           <a:xfrm>
             <a:off x="457200" y="1883664"/>
-            <a:ext cx="7772400" cy="1600200"/>
+            <a:ext cx="5029200" cy="1627632"/>
           </a:xfrm>
           <a:prstGeom prst="rect">
             <a:avLst/>
@@ -9918,7 +9918,7 @@
                   <a:srgbClr val="1A1A1A"/>
                 </a:solidFill>
               </a:rPr>
-              <a:t>•  Multiple siRNA/shRNA constructs screened in a single endpoint confluency assay</a:t>
+              <a:t>•  75 perturbagens screened in a single endpoint confluency assay</a:t>
             </a:r>
           </a:p>
           <a:p>
@@ -9933,7 +9933,7 @@
                   <a:srgbClr val="1A1A1A"/>
                 </a:solidFill>
               </a:rPr>
-              <a:t>•  Normalised confluency (%) reported per perturbagen relative to non-targeting control (set to 100%)</a:t>
+              <a:t>•  Values above 100% = enhanced growth; below 100% = growth inhibition</a:t>
             </a:r>
           </a:p>
           <a:p>
@@ -9948,9 +9948,1952 @@
                   <a:srgbClr val="1A1A1A"/>
                 </a:solidFill>
               </a:rPr>
-              <a:t>•  Values above 100% indicate enhanced growth; below 100% indicate growth inhibition</a:t>
-            </a:r>
-          </a:p>
+              <a:t>•  Identifies candidate genes whose knockdown significantly alters cell proliferation</a:t>
+            </a:r>
+          </a:p>
+        </p:txBody>
+      </p:sp>
+      <p:sp>
+        <p:nvSpPr>
+          <p:cNvPr id="13" name="TextBox 12"/>
+          <p:cNvSpPr txBox="1"/>
+          <p:nvPr/>
+        </p:nvSpPr>
+        <p:spPr>
+          <a:xfrm>
+            <a:off x="5669280" y="1883664"/>
+            <a:ext cx="5989320" cy="256032"/>
+          </a:xfrm>
+          <a:prstGeom prst="rect">
+            <a:avLst/>
+          </a:prstGeom>
+          <a:noFill/>
+        </p:spPr>
+        <p:txBody>
+          <a:bodyPr wrap="square">
+            <a:spAutoFit/>
+          </a:bodyPr>
+          <a:lstStyle/>
+          <a:p>
+            <a:pPr algn="l"/>
+            <a:r>
+              <a:rPr sz="1100" b="1" i="0">
+                <a:solidFill>
+                  <a:srgbClr val="1A375E"/>
+                </a:solidFill>
+              </a:rPr>
+              <a:t>Notable Hits  (48 h confluency vs. control)</a:t>
+            </a:r>
+          </a:p>
+        </p:txBody>
+      </p:sp>
+      <p:sp>
+        <p:nvSpPr>
+          <p:cNvPr id="14" name="Rectangle 13"/>
+          <p:cNvSpPr/>
+          <p:nvPr/>
+        </p:nvSpPr>
+        <p:spPr>
+          <a:xfrm>
+            <a:off x="5669280" y="2176272"/>
+            <a:ext cx="1463040" cy="274320"/>
+          </a:xfrm>
+          <a:prstGeom prst="rect">
+            <a:avLst/>
+          </a:prstGeom>
+          <a:solidFill>
+            <a:srgbClr val="1A375E"/>
+          </a:solidFill>
+          <a:ln>
+            <a:noFill/>
+          </a:ln>
+        </p:spPr>
+        <p:style>
+          <a:lnRef idx="1">
+            <a:schemeClr val="accent1"/>
+          </a:lnRef>
+          <a:fillRef idx="3">
+            <a:schemeClr val="accent1"/>
+          </a:fillRef>
+          <a:effectRef idx="2">
+            <a:schemeClr val="accent1"/>
+          </a:effectRef>
+          <a:fontRef idx="minor">
+            <a:schemeClr val="lt1"/>
+          </a:fontRef>
+        </p:style>
+        <p:txBody>
+          <a:bodyPr rtlCol="0" anchor="ctr"/>
+          <a:lstStyle/>
+          <a:p>
+            <a:pPr algn="ctr"/>
+          </a:p>
+        </p:txBody>
+      </p:sp>
+      <p:sp>
+        <p:nvSpPr>
+          <p:cNvPr id="15" name="TextBox 14"/>
+          <p:cNvSpPr txBox="1"/>
+          <p:nvPr/>
+        </p:nvSpPr>
+        <p:spPr>
+          <a:xfrm>
+            <a:off x="5715000" y="2203704"/>
+            <a:ext cx="1389888" cy="219456"/>
+          </a:xfrm>
+          <a:prstGeom prst="rect">
+            <a:avLst/>
+          </a:prstGeom>
+          <a:noFill/>
+        </p:spPr>
+        <p:txBody>
+          <a:bodyPr wrap="square">
+            <a:spAutoFit/>
+          </a:bodyPr>
+          <a:lstStyle/>
+          <a:p>
+            <a:pPr algn="ctr"/>
+            <a:r>
+              <a:rPr sz="1000" b="1" i="0">
+                <a:solidFill>
+                  <a:srgbClr val="FFFFFF"/>
+                </a:solidFill>
+              </a:rPr>
+              <a:t>Target</a:t>
+            </a:r>
+          </a:p>
+        </p:txBody>
+      </p:sp>
+      <p:sp>
+        <p:nvSpPr>
+          <p:cNvPr id="16" name="Rectangle 15"/>
+          <p:cNvSpPr/>
+          <p:nvPr/>
+        </p:nvSpPr>
+        <p:spPr>
+          <a:xfrm>
+            <a:off x="7150608" y="2176272"/>
+            <a:ext cx="1554480" cy="274320"/>
+          </a:xfrm>
+          <a:prstGeom prst="rect">
+            <a:avLst/>
+          </a:prstGeom>
+          <a:solidFill>
+            <a:srgbClr val="1A375E"/>
+          </a:solidFill>
+          <a:ln>
+            <a:noFill/>
+          </a:ln>
+        </p:spPr>
+        <p:style>
+          <a:lnRef idx="1">
+            <a:schemeClr val="accent1"/>
+          </a:lnRef>
+          <a:fillRef idx="3">
+            <a:schemeClr val="accent1"/>
+          </a:fillRef>
+          <a:effectRef idx="2">
+            <a:schemeClr val="accent1"/>
+          </a:effectRef>
+          <a:fontRef idx="minor">
+            <a:schemeClr val="lt1"/>
+          </a:fontRef>
+        </p:style>
+        <p:txBody>
+          <a:bodyPr rtlCol="0" anchor="ctr"/>
+          <a:lstStyle/>
+          <a:p>
+            <a:pPr algn="ctr"/>
+          </a:p>
+        </p:txBody>
+      </p:sp>
+      <p:sp>
+        <p:nvSpPr>
+          <p:cNvPr id="17" name="TextBox 16"/>
+          <p:cNvSpPr txBox="1"/>
+          <p:nvPr/>
+        </p:nvSpPr>
+        <p:spPr>
+          <a:xfrm>
+            <a:off x="7196328" y="2203704"/>
+            <a:ext cx="1481328" cy="219456"/>
+          </a:xfrm>
+          <a:prstGeom prst="rect">
+            <a:avLst/>
+          </a:prstGeom>
+          <a:noFill/>
+        </p:spPr>
+        <p:txBody>
+          <a:bodyPr wrap="square">
+            <a:spAutoFit/>
+          </a:bodyPr>
+          <a:lstStyle/>
+          <a:p>
+            <a:pPr algn="ctr"/>
+            <a:r>
+              <a:rPr sz="1000" b="1" i="0">
+                <a:solidFill>
+                  <a:srgbClr val="FFFFFF"/>
+                </a:solidFill>
+              </a:rPr>
+              <a:t>Confluency %</a:t>
+            </a:r>
+          </a:p>
+        </p:txBody>
+      </p:sp>
+      <p:sp>
+        <p:nvSpPr>
+          <p:cNvPr id="18" name="Rectangle 17"/>
+          <p:cNvSpPr/>
+          <p:nvPr/>
+        </p:nvSpPr>
+        <p:spPr>
+          <a:xfrm>
+            <a:off x="8723376" y="2176272"/>
+            <a:ext cx="2606040" cy="274320"/>
+          </a:xfrm>
+          <a:prstGeom prst="rect">
+            <a:avLst/>
+          </a:prstGeom>
+          <a:solidFill>
+            <a:srgbClr val="1A375E"/>
+          </a:solidFill>
+          <a:ln>
+            <a:noFill/>
+          </a:ln>
+        </p:spPr>
+        <p:style>
+          <a:lnRef idx="1">
+            <a:schemeClr val="accent1"/>
+          </a:lnRef>
+          <a:fillRef idx="3">
+            <a:schemeClr val="accent1"/>
+          </a:fillRef>
+          <a:effectRef idx="2">
+            <a:schemeClr val="accent1"/>
+          </a:effectRef>
+          <a:fontRef idx="minor">
+            <a:schemeClr val="lt1"/>
+          </a:fontRef>
+        </p:style>
+        <p:txBody>
+          <a:bodyPr rtlCol="0" anchor="ctr"/>
+          <a:lstStyle/>
+          <a:p>
+            <a:pPr algn="ctr"/>
+          </a:p>
+        </p:txBody>
+      </p:sp>
+      <p:sp>
+        <p:nvSpPr>
+          <p:cNvPr id="19" name="TextBox 18"/>
+          <p:cNvSpPr txBox="1"/>
+          <p:nvPr/>
+        </p:nvSpPr>
+        <p:spPr>
+          <a:xfrm>
+            <a:off x="8769096" y="2203704"/>
+            <a:ext cx="2532888" cy="219456"/>
+          </a:xfrm>
+          <a:prstGeom prst="rect">
+            <a:avLst/>
+          </a:prstGeom>
+          <a:noFill/>
+        </p:spPr>
+        <p:txBody>
+          <a:bodyPr wrap="square">
+            <a:spAutoFit/>
+          </a:bodyPr>
+          <a:lstStyle/>
+          <a:p>
+            <a:pPr algn="ctr"/>
+            <a:r>
+              <a:rPr sz="1000" b="1" i="0">
+                <a:solidFill>
+                  <a:srgbClr val="FFFFFF"/>
+                </a:solidFill>
+              </a:rPr>
+              <a:t>Effect</a:t>
+            </a:r>
+          </a:p>
+        </p:txBody>
+      </p:sp>
+      <p:sp>
+        <p:nvSpPr>
+          <p:cNvPr id="20" name="Rectangle 19"/>
+          <p:cNvSpPr/>
+          <p:nvPr/>
+        </p:nvSpPr>
+        <p:spPr>
+          <a:xfrm>
+            <a:off x="5669280" y="2450592"/>
+            <a:ext cx="1463040" cy="292608"/>
+          </a:xfrm>
+          <a:prstGeom prst="rect">
+            <a:avLst/>
+          </a:prstGeom>
+          <a:solidFill>
+            <a:srgbClr val="E2EFDA"/>
+          </a:solidFill>
+          <a:ln w="5080">
+            <a:solidFill>
+              <a:srgbClr val="CCCCCC"/>
+            </a:solidFill>
+          </a:ln>
+        </p:spPr>
+        <p:style>
+          <a:lnRef idx="1">
+            <a:schemeClr val="accent1"/>
+          </a:lnRef>
+          <a:fillRef idx="3">
+            <a:schemeClr val="accent1"/>
+          </a:fillRef>
+          <a:effectRef idx="2">
+            <a:schemeClr val="accent1"/>
+          </a:effectRef>
+          <a:fontRef idx="minor">
+            <a:schemeClr val="lt1"/>
+          </a:fontRef>
+        </p:style>
+        <p:txBody>
+          <a:bodyPr rtlCol="0" anchor="ctr"/>
+          <a:lstStyle/>
+          <a:p>
+            <a:pPr algn="ctr"/>
+          </a:p>
+        </p:txBody>
+      </p:sp>
+      <p:sp>
+        <p:nvSpPr>
+          <p:cNvPr id="21" name="TextBox 20"/>
+          <p:cNvSpPr txBox="1"/>
+          <p:nvPr/>
+        </p:nvSpPr>
+        <p:spPr>
+          <a:xfrm>
+            <a:off x="5715000" y="2496312"/>
+            <a:ext cx="1389888" cy="219456"/>
+          </a:xfrm>
+          <a:prstGeom prst="rect">
+            <a:avLst/>
+          </a:prstGeom>
+          <a:noFill/>
+        </p:spPr>
+        <p:txBody>
+          <a:bodyPr wrap="square">
+            <a:spAutoFit/>
+          </a:bodyPr>
+          <a:lstStyle/>
+          <a:p>
+            <a:pPr algn="l"/>
+            <a:r>
+              <a:rPr sz="1000" b="1" i="0">
+                <a:solidFill>
+                  <a:srgbClr val="379637"/>
+                </a:solidFill>
+              </a:rPr>
+              <a:t>GeneBK</a:t>
+            </a:r>
+          </a:p>
+        </p:txBody>
+      </p:sp>
+      <p:sp>
+        <p:nvSpPr>
+          <p:cNvPr id="22" name="Rectangle 21"/>
+          <p:cNvSpPr/>
+          <p:nvPr/>
+        </p:nvSpPr>
+        <p:spPr>
+          <a:xfrm>
+            <a:off x="7150608" y="2450592"/>
+            <a:ext cx="1554480" cy="292608"/>
+          </a:xfrm>
+          <a:prstGeom prst="rect">
+            <a:avLst/>
+          </a:prstGeom>
+          <a:solidFill>
+            <a:srgbClr val="E2EFDA"/>
+          </a:solidFill>
+          <a:ln w="5080">
+            <a:solidFill>
+              <a:srgbClr val="CCCCCC"/>
+            </a:solidFill>
+          </a:ln>
+        </p:spPr>
+        <p:style>
+          <a:lnRef idx="1">
+            <a:schemeClr val="accent1"/>
+          </a:lnRef>
+          <a:fillRef idx="3">
+            <a:schemeClr val="accent1"/>
+          </a:fillRef>
+          <a:effectRef idx="2">
+            <a:schemeClr val="accent1"/>
+          </a:effectRef>
+          <a:fontRef idx="minor">
+            <a:schemeClr val="lt1"/>
+          </a:fontRef>
+        </p:style>
+        <p:txBody>
+          <a:bodyPr rtlCol="0" anchor="ctr"/>
+          <a:lstStyle/>
+          <a:p>
+            <a:pPr algn="ctr"/>
+          </a:p>
+        </p:txBody>
+      </p:sp>
+      <p:sp>
+        <p:nvSpPr>
+          <p:cNvPr id="23" name="TextBox 22"/>
+          <p:cNvSpPr txBox="1"/>
+          <p:nvPr/>
+        </p:nvSpPr>
+        <p:spPr>
+          <a:xfrm>
+            <a:off x="7196328" y="2496312"/>
+            <a:ext cx="1481328" cy="219456"/>
+          </a:xfrm>
+          <a:prstGeom prst="rect">
+            <a:avLst/>
+          </a:prstGeom>
+          <a:noFill/>
+        </p:spPr>
+        <p:txBody>
+          <a:bodyPr wrap="square">
+            <a:spAutoFit/>
+          </a:bodyPr>
+          <a:lstStyle/>
+          <a:p>
+            <a:pPr algn="ctr"/>
+            <a:r>
+              <a:rPr sz="1000" b="0" i="0">
+                <a:solidFill>
+                  <a:srgbClr val="379637"/>
+                </a:solidFill>
+              </a:rPr>
+              <a:t>65.2%</a:t>
+            </a:r>
+          </a:p>
+        </p:txBody>
+      </p:sp>
+      <p:sp>
+        <p:nvSpPr>
+          <p:cNvPr id="24" name="Rectangle 23"/>
+          <p:cNvSpPr/>
+          <p:nvPr/>
+        </p:nvSpPr>
+        <p:spPr>
+          <a:xfrm>
+            <a:off x="8723376" y="2450592"/>
+            <a:ext cx="2606040" cy="292608"/>
+          </a:xfrm>
+          <a:prstGeom prst="rect">
+            <a:avLst/>
+          </a:prstGeom>
+          <a:solidFill>
+            <a:srgbClr val="E2EFDA"/>
+          </a:solidFill>
+          <a:ln w="5080">
+            <a:solidFill>
+              <a:srgbClr val="CCCCCC"/>
+            </a:solidFill>
+          </a:ln>
+        </p:spPr>
+        <p:style>
+          <a:lnRef idx="1">
+            <a:schemeClr val="accent1"/>
+          </a:lnRef>
+          <a:fillRef idx="3">
+            <a:schemeClr val="accent1"/>
+          </a:fillRef>
+          <a:effectRef idx="2">
+            <a:schemeClr val="accent1"/>
+          </a:effectRef>
+          <a:fontRef idx="minor">
+            <a:schemeClr val="lt1"/>
+          </a:fontRef>
+        </p:style>
+        <p:txBody>
+          <a:bodyPr rtlCol="0" anchor="ctr"/>
+          <a:lstStyle/>
+          <a:p>
+            <a:pPr algn="ctr"/>
+          </a:p>
+        </p:txBody>
+      </p:sp>
+      <p:sp>
+        <p:nvSpPr>
+          <p:cNvPr id="25" name="TextBox 24"/>
+          <p:cNvSpPr txBox="1"/>
+          <p:nvPr/>
+        </p:nvSpPr>
+        <p:spPr>
+          <a:xfrm>
+            <a:off x="8769096" y="2496312"/>
+            <a:ext cx="2532888" cy="219456"/>
+          </a:xfrm>
+          <a:prstGeom prst="rect">
+            <a:avLst/>
+          </a:prstGeom>
+          <a:noFill/>
+        </p:spPr>
+        <p:txBody>
+          <a:bodyPr wrap="square">
+            <a:spAutoFit/>
+          </a:bodyPr>
+          <a:lstStyle/>
+          <a:p>
+            <a:pPr algn="l"/>
+            <a:r>
+              <a:rPr sz="1000" b="0" i="0">
+                <a:solidFill>
+                  <a:srgbClr val="1A1A1A"/>
+                </a:solidFill>
+              </a:rPr>
+              <a:t>↓ Growth inhibition</a:t>
+            </a:r>
+          </a:p>
+        </p:txBody>
+      </p:sp>
+      <p:sp>
+        <p:nvSpPr>
+          <p:cNvPr id="26" name="Rectangle 25"/>
+          <p:cNvSpPr/>
+          <p:nvPr/>
+        </p:nvSpPr>
+        <p:spPr>
+          <a:xfrm>
+            <a:off x="5669280" y="2761488"/>
+            <a:ext cx="1463040" cy="292608"/>
+          </a:xfrm>
+          <a:prstGeom prst="rect">
+            <a:avLst/>
+          </a:prstGeom>
+          <a:solidFill>
+            <a:srgbClr val="FFFFFF"/>
+          </a:solidFill>
+          <a:ln w="5080">
+            <a:solidFill>
+              <a:srgbClr val="CCCCCC"/>
+            </a:solidFill>
+          </a:ln>
+        </p:spPr>
+        <p:style>
+          <a:lnRef idx="1">
+            <a:schemeClr val="accent1"/>
+          </a:lnRef>
+          <a:fillRef idx="3">
+            <a:schemeClr val="accent1"/>
+          </a:fillRef>
+          <a:effectRef idx="2">
+            <a:schemeClr val="accent1"/>
+          </a:effectRef>
+          <a:fontRef idx="minor">
+            <a:schemeClr val="lt1"/>
+          </a:fontRef>
+        </p:style>
+        <p:txBody>
+          <a:bodyPr rtlCol="0" anchor="ctr"/>
+          <a:lstStyle/>
+          <a:p>
+            <a:pPr algn="ctr"/>
+          </a:p>
+        </p:txBody>
+      </p:sp>
+      <p:sp>
+        <p:nvSpPr>
+          <p:cNvPr id="27" name="TextBox 26"/>
+          <p:cNvSpPr txBox="1"/>
+          <p:nvPr/>
+        </p:nvSpPr>
+        <p:spPr>
+          <a:xfrm>
+            <a:off x="5715000" y="2807208"/>
+            <a:ext cx="1389888" cy="219456"/>
+          </a:xfrm>
+          <a:prstGeom prst="rect">
+            <a:avLst/>
+          </a:prstGeom>
+          <a:noFill/>
+        </p:spPr>
+        <p:txBody>
+          <a:bodyPr wrap="square">
+            <a:spAutoFit/>
+          </a:bodyPr>
+          <a:lstStyle/>
+          <a:p>
+            <a:pPr algn="l"/>
+            <a:r>
+              <a:rPr sz="1000" b="1" i="0">
+                <a:solidFill>
+                  <a:srgbClr val="379637"/>
+                </a:solidFill>
+              </a:rPr>
+              <a:t>GeneBI</a:t>
+            </a:r>
+          </a:p>
+        </p:txBody>
+      </p:sp>
+      <p:sp>
+        <p:nvSpPr>
+          <p:cNvPr id="28" name="Rectangle 27"/>
+          <p:cNvSpPr/>
+          <p:nvPr/>
+        </p:nvSpPr>
+        <p:spPr>
+          <a:xfrm>
+            <a:off x="7150608" y="2761488"/>
+            <a:ext cx="1554480" cy="292608"/>
+          </a:xfrm>
+          <a:prstGeom prst="rect">
+            <a:avLst/>
+          </a:prstGeom>
+          <a:solidFill>
+            <a:srgbClr val="FFFFFF"/>
+          </a:solidFill>
+          <a:ln w="5080">
+            <a:solidFill>
+              <a:srgbClr val="CCCCCC"/>
+            </a:solidFill>
+          </a:ln>
+        </p:spPr>
+        <p:style>
+          <a:lnRef idx="1">
+            <a:schemeClr val="accent1"/>
+          </a:lnRef>
+          <a:fillRef idx="3">
+            <a:schemeClr val="accent1"/>
+          </a:fillRef>
+          <a:effectRef idx="2">
+            <a:schemeClr val="accent1"/>
+          </a:effectRef>
+          <a:fontRef idx="minor">
+            <a:schemeClr val="lt1"/>
+          </a:fontRef>
+        </p:style>
+        <p:txBody>
+          <a:bodyPr rtlCol="0" anchor="ctr"/>
+          <a:lstStyle/>
+          <a:p>
+            <a:pPr algn="ctr"/>
+          </a:p>
+        </p:txBody>
+      </p:sp>
+      <p:sp>
+        <p:nvSpPr>
+          <p:cNvPr id="29" name="TextBox 28"/>
+          <p:cNvSpPr txBox="1"/>
+          <p:nvPr/>
+        </p:nvSpPr>
+        <p:spPr>
+          <a:xfrm>
+            <a:off x="7196328" y="2807208"/>
+            <a:ext cx="1481328" cy="219456"/>
+          </a:xfrm>
+          <a:prstGeom prst="rect">
+            <a:avLst/>
+          </a:prstGeom>
+          <a:noFill/>
+        </p:spPr>
+        <p:txBody>
+          <a:bodyPr wrap="square">
+            <a:spAutoFit/>
+          </a:bodyPr>
+          <a:lstStyle/>
+          <a:p>
+            <a:pPr algn="ctr"/>
+            <a:r>
+              <a:rPr sz="1000" b="0" i="0">
+                <a:solidFill>
+                  <a:srgbClr val="379637"/>
+                </a:solidFill>
+              </a:rPr>
+              <a:t>79.1%</a:t>
+            </a:r>
+          </a:p>
+        </p:txBody>
+      </p:sp>
+      <p:sp>
+        <p:nvSpPr>
+          <p:cNvPr id="30" name="Rectangle 29"/>
+          <p:cNvSpPr/>
+          <p:nvPr/>
+        </p:nvSpPr>
+        <p:spPr>
+          <a:xfrm>
+            <a:off x="8723376" y="2761488"/>
+            <a:ext cx="2606040" cy="292608"/>
+          </a:xfrm>
+          <a:prstGeom prst="rect">
+            <a:avLst/>
+          </a:prstGeom>
+          <a:solidFill>
+            <a:srgbClr val="FFFFFF"/>
+          </a:solidFill>
+          <a:ln w="5080">
+            <a:solidFill>
+              <a:srgbClr val="CCCCCC"/>
+            </a:solidFill>
+          </a:ln>
+        </p:spPr>
+        <p:style>
+          <a:lnRef idx="1">
+            <a:schemeClr val="accent1"/>
+          </a:lnRef>
+          <a:fillRef idx="3">
+            <a:schemeClr val="accent1"/>
+          </a:fillRef>
+          <a:effectRef idx="2">
+            <a:schemeClr val="accent1"/>
+          </a:effectRef>
+          <a:fontRef idx="minor">
+            <a:schemeClr val="lt1"/>
+          </a:fontRef>
+        </p:style>
+        <p:txBody>
+          <a:bodyPr rtlCol="0" anchor="ctr"/>
+          <a:lstStyle/>
+          <a:p>
+            <a:pPr algn="ctr"/>
+          </a:p>
+        </p:txBody>
+      </p:sp>
+      <p:sp>
+        <p:nvSpPr>
+          <p:cNvPr id="31" name="TextBox 30"/>
+          <p:cNvSpPr txBox="1"/>
+          <p:nvPr/>
+        </p:nvSpPr>
+        <p:spPr>
+          <a:xfrm>
+            <a:off x="8769096" y="2807208"/>
+            <a:ext cx="2532888" cy="219456"/>
+          </a:xfrm>
+          <a:prstGeom prst="rect">
+            <a:avLst/>
+          </a:prstGeom>
+          <a:noFill/>
+        </p:spPr>
+        <p:txBody>
+          <a:bodyPr wrap="square">
+            <a:spAutoFit/>
+          </a:bodyPr>
+          <a:lstStyle/>
+          <a:p>
+            <a:pPr algn="l"/>
+            <a:r>
+              <a:rPr sz="1000" b="0" i="0">
+                <a:solidFill>
+                  <a:srgbClr val="1A1A1A"/>
+                </a:solidFill>
+              </a:rPr>
+              <a:t>↓ Growth inhibition</a:t>
+            </a:r>
+          </a:p>
+        </p:txBody>
+      </p:sp>
+      <p:sp>
+        <p:nvSpPr>
+          <p:cNvPr id="32" name="Rectangle 31"/>
+          <p:cNvSpPr/>
+          <p:nvPr/>
+        </p:nvSpPr>
+        <p:spPr>
+          <a:xfrm>
+            <a:off x="5669280" y="3072384"/>
+            <a:ext cx="1463040" cy="292608"/>
+          </a:xfrm>
+          <a:prstGeom prst="rect">
+            <a:avLst/>
+          </a:prstGeom>
+          <a:solidFill>
+            <a:srgbClr val="E2EFDA"/>
+          </a:solidFill>
+          <a:ln w="5080">
+            <a:solidFill>
+              <a:srgbClr val="CCCCCC"/>
+            </a:solidFill>
+          </a:ln>
+        </p:spPr>
+        <p:style>
+          <a:lnRef idx="1">
+            <a:schemeClr val="accent1"/>
+          </a:lnRef>
+          <a:fillRef idx="3">
+            <a:schemeClr val="accent1"/>
+          </a:fillRef>
+          <a:effectRef idx="2">
+            <a:schemeClr val="accent1"/>
+          </a:effectRef>
+          <a:fontRef idx="minor">
+            <a:schemeClr val="lt1"/>
+          </a:fontRef>
+        </p:style>
+        <p:txBody>
+          <a:bodyPr rtlCol="0" anchor="ctr"/>
+          <a:lstStyle/>
+          <a:p>
+            <a:pPr algn="ctr"/>
+          </a:p>
+        </p:txBody>
+      </p:sp>
+      <p:sp>
+        <p:nvSpPr>
+          <p:cNvPr id="33" name="TextBox 32"/>
+          <p:cNvSpPr txBox="1"/>
+          <p:nvPr/>
+        </p:nvSpPr>
+        <p:spPr>
+          <a:xfrm>
+            <a:off x="5715000" y="3118104"/>
+            <a:ext cx="1389888" cy="219456"/>
+          </a:xfrm>
+          <a:prstGeom prst="rect">
+            <a:avLst/>
+          </a:prstGeom>
+          <a:noFill/>
+        </p:spPr>
+        <p:txBody>
+          <a:bodyPr wrap="square">
+            <a:spAutoFit/>
+          </a:bodyPr>
+          <a:lstStyle/>
+          <a:p>
+            <a:pPr algn="l"/>
+            <a:r>
+              <a:rPr sz="1000" b="1" i="0">
+                <a:solidFill>
+                  <a:srgbClr val="379637"/>
+                </a:solidFill>
+              </a:rPr>
+              <a:t>GeneAG</a:t>
+            </a:r>
+          </a:p>
+        </p:txBody>
+      </p:sp>
+      <p:sp>
+        <p:nvSpPr>
+          <p:cNvPr id="34" name="Rectangle 33"/>
+          <p:cNvSpPr/>
+          <p:nvPr/>
+        </p:nvSpPr>
+        <p:spPr>
+          <a:xfrm>
+            <a:off x="7150608" y="3072384"/>
+            <a:ext cx="1554480" cy="292608"/>
+          </a:xfrm>
+          <a:prstGeom prst="rect">
+            <a:avLst/>
+          </a:prstGeom>
+          <a:solidFill>
+            <a:srgbClr val="E2EFDA"/>
+          </a:solidFill>
+          <a:ln w="5080">
+            <a:solidFill>
+              <a:srgbClr val="CCCCCC"/>
+            </a:solidFill>
+          </a:ln>
+        </p:spPr>
+        <p:style>
+          <a:lnRef idx="1">
+            <a:schemeClr val="accent1"/>
+          </a:lnRef>
+          <a:fillRef idx="3">
+            <a:schemeClr val="accent1"/>
+          </a:fillRef>
+          <a:effectRef idx="2">
+            <a:schemeClr val="accent1"/>
+          </a:effectRef>
+          <a:fontRef idx="minor">
+            <a:schemeClr val="lt1"/>
+          </a:fontRef>
+        </p:style>
+        <p:txBody>
+          <a:bodyPr rtlCol="0" anchor="ctr"/>
+          <a:lstStyle/>
+          <a:p>
+            <a:pPr algn="ctr"/>
+          </a:p>
+        </p:txBody>
+      </p:sp>
+      <p:sp>
+        <p:nvSpPr>
+          <p:cNvPr id="35" name="TextBox 34"/>
+          <p:cNvSpPr txBox="1"/>
+          <p:nvPr/>
+        </p:nvSpPr>
+        <p:spPr>
+          <a:xfrm>
+            <a:off x="7196328" y="3118104"/>
+            <a:ext cx="1481328" cy="219456"/>
+          </a:xfrm>
+          <a:prstGeom prst="rect">
+            <a:avLst/>
+          </a:prstGeom>
+          <a:noFill/>
+        </p:spPr>
+        <p:txBody>
+          <a:bodyPr wrap="square">
+            <a:spAutoFit/>
+          </a:bodyPr>
+          <a:lstStyle/>
+          <a:p>
+            <a:pPr algn="ctr"/>
+            <a:r>
+              <a:rPr sz="1000" b="0" i="0">
+                <a:solidFill>
+                  <a:srgbClr val="379637"/>
+                </a:solidFill>
+              </a:rPr>
+              <a:t>79.9%</a:t>
+            </a:r>
+          </a:p>
+        </p:txBody>
+      </p:sp>
+      <p:sp>
+        <p:nvSpPr>
+          <p:cNvPr id="36" name="Rectangle 35"/>
+          <p:cNvSpPr/>
+          <p:nvPr/>
+        </p:nvSpPr>
+        <p:spPr>
+          <a:xfrm>
+            <a:off x="8723376" y="3072384"/>
+            <a:ext cx="2606040" cy="292608"/>
+          </a:xfrm>
+          <a:prstGeom prst="rect">
+            <a:avLst/>
+          </a:prstGeom>
+          <a:solidFill>
+            <a:srgbClr val="E2EFDA"/>
+          </a:solidFill>
+          <a:ln w="5080">
+            <a:solidFill>
+              <a:srgbClr val="CCCCCC"/>
+            </a:solidFill>
+          </a:ln>
+        </p:spPr>
+        <p:style>
+          <a:lnRef idx="1">
+            <a:schemeClr val="accent1"/>
+          </a:lnRef>
+          <a:fillRef idx="3">
+            <a:schemeClr val="accent1"/>
+          </a:fillRef>
+          <a:effectRef idx="2">
+            <a:schemeClr val="accent1"/>
+          </a:effectRef>
+          <a:fontRef idx="minor">
+            <a:schemeClr val="lt1"/>
+          </a:fontRef>
+        </p:style>
+        <p:txBody>
+          <a:bodyPr rtlCol="0" anchor="ctr"/>
+          <a:lstStyle/>
+          <a:p>
+            <a:pPr algn="ctr"/>
+          </a:p>
+        </p:txBody>
+      </p:sp>
+      <p:sp>
+        <p:nvSpPr>
+          <p:cNvPr id="37" name="TextBox 36"/>
+          <p:cNvSpPr txBox="1"/>
+          <p:nvPr/>
+        </p:nvSpPr>
+        <p:spPr>
+          <a:xfrm>
+            <a:off x="8769096" y="3118104"/>
+            <a:ext cx="2532888" cy="219456"/>
+          </a:xfrm>
+          <a:prstGeom prst="rect">
+            <a:avLst/>
+          </a:prstGeom>
+          <a:noFill/>
+        </p:spPr>
+        <p:txBody>
+          <a:bodyPr wrap="square">
+            <a:spAutoFit/>
+          </a:bodyPr>
+          <a:lstStyle/>
+          <a:p>
+            <a:pPr algn="l"/>
+            <a:r>
+              <a:rPr sz="1000" b="0" i="0">
+                <a:solidFill>
+                  <a:srgbClr val="1A1A1A"/>
+                </a:solidFill>
+              </a:rPr>
+              <a:t>↓ Growth inhibition</a:t>
+            </a:r>
+          </a:p>
+        </p:txBody>
+      </p:sp>
+      <p:sp>
+        <p:nvSpPr>
+          <p:cNvPr id="38" name="Rectangle 37"/>
+          <p:cNvSpPr/>
+          <p:nvPr/>
+        </p:nvSpPr>
+        <p:spPr>
+          <a:xfrm>
+            <a:off x="5669280" y="3383280"/>
+            <a:ext cx="1463040" cy="292608"/>
+          </a:xfrm>
+          <a:prstGeom prst="rect">
+            <a:avLst/>
+          </a:prstGeom>
+          <a:solidFill>
+            <a:srgbClr val="FFF3E8"/>
+          </a:solidFill>
+          <a:ln w="5080">
+            <a:solidFill>
+              <a:srgbClr val="CCCCCC"/>
+            </a:solidFill>
+          </a:ln>
+        </p:spPr>
+        <p:style>
+          <a:lnRef idx="1">
+            <a:schemeClr val="accent1"/>
+          </a:lnRef>
+          <a:fillRef idx="3">
+            <a:schemeClr val="accent1"/>
+          </a:fillRef>
+          <a:effectRef idx="2">
+            <a:schemeClr val="accent1"/>
+          </a:effectRef>
+          <a:fontRef idx="minor">
+            <a:schemeClr val="lt1"/>
+          </a:fontRef>
+        </p:style>
+        <p:txBody>
+          <a:bodyPr rtlCol="0" anchor="ctr"/>
+          <a:lstStyle/>
+          <a:p>
+            <a:pPr algn="ctr"/>
+          </a:p>
+        </p:txBody>
+      </p:sp>
+      <p:sp>
+        <p:nvSpPr>
+          <p:cNvPr id="39" name="TextBox 38"/>
+          <p:cNvSpPr txBox="1"/>
+          <p:nvPr/>
+        </p:nvSpPr>
+        <p:spPr>
+          <a:xfrm>
+            <a:off x="5715000" y="3429000"/>
+            <a:ext cx="1389888" cy="219456"/>
+          </a:xfrm>
+          <a:prstGeom prst="rect">
+            <a:avLst/>
+          </a:prstGeom>
+          <a:noFill/>
+        </p:spPr>
+        <p:txBody>
+          <a:bodyPr wrap="square">
+            <a:spAutoFit/>
+          </a:bodyPr>
+          <a:lstStyle/>
+          <a:p>
+            <a:pPr algn="l"/>
+            <a:r>
+              <a:rPr sz="1000" b="1" i="0">
+                <a:solidFill>
+                  <a:srgbClr val="C55A11"/>
+                </a:solidFill>
+              </a:rPr>
+              <a:t>GeneAC</a:t>
+            </a:r>
+          </a:p>
+        </p:txBody>
+      </p:sp>
+      <p:sp>
+        <p:nvSpPr>
+          <p:cNvPr id="40" name="Rectangle 39"/>
+          <p:cNvSpPr/>
+          <p:nvPr/>
+        </p:nvSpPr>
+        <p:spPr>
+          <a:xfrm>
+            <a:off x="7150608" y="3383280"/>
+            <a:ext cx="1554480" cy="292608"/>
+          </a:xfrm>
+          <a:prstGeom prst="rect">
+            <a:avLst/>
+          </a:prstGeom>
+          <a:solidFill>
+            <a:srgbClr val="FFF3E8"/>
+          </a:solidFill>
+          <a:ln w="5080">
+            <a:solidFill>
+              <a:srgbClr val="CCCCCC"/>
+            </a:solidFill>
+          </a:ln>
+        </p:spPr>
+        <p:style>
+          <a:lnRef idx="1">
+            <a:schemeClr val="accent1"/>
+          </a:lnRef>
+          <a:fillRef idx="3">
+            <a:schemeClr val="accent1"/>
+          </a:fillRef>
+          <a:effectRef idx="2">
+            <a:schemeClr val="accent1"/>
+          </a:effectRef>
+          <a:fontRef idx="minor">
+            <a:schemeClr val="lt1"/>
+          </a:fontRef>
+        </p:style>
+        <p:txBody>
+          <a:bodyPr rtlCol="0" anchor="ctr"/>
+          <a:lstStyle/>
+          <a:p>
+            <a:pPr algn="ctr"/>
+          </a:p>
+        </p:txBody>
+      </p:sp>
+      <p:sp>
+        <p:nvSpPr>
+          <p:cNvPr id="41" name="TextBox 40"/>
+          <p:cNvSpPr txBox="1"/>
+          <p:nvPr/>
+        </p:nvSpPr>
+        <p:spPr>
+          <a:xfrm>
+            <a:off x="7196328" y="3429000"/>
+            <a:ext cx="1481328" cy="219456"/>
+          </a:xfrm>
+          <a:prstGeom prst="rect">
+            <a:avLst/>
+          </a:prstGeom>
+          <a:noFill/>
+        </p:spPr>
+        <p:txBody>
+          <a:bodyPr wrap="square">
+            <a:spAutoFit/>
+          </a:bodyPr>
+          <a:lstStyle/>
+          <a:p>
+            <a:pPr algn="ctr"/>
+            <a:r>
+              <a:rPr sz="1000" b="0" i="0">
+                <a:solidFill>
+                  <a:srgbClr val="C55A11"/>
+                </a:solidFill>
+              </a:rPr>
+              <a:t>126.1%</a:t>
+            </a:r>
+          </a:p>
+        </p:txBody>
+      </p:sp>
+      <p:sp>
+        <p:nvSpPr>
+          <p:cNvPr id="42" name="Rectangle 41"/>
+          <p:cNvSpPr/>
+          <p:nvPr/>
+        </p:nvSpPr>
+        <p:spPr>
+          <a:xfrm>
+            <a:off x="8723376" y="3383280"/>
+            <a:ext cx="2606040" cy="292608"/>
+          </a:xfrm>
+          <a:prstGeom prst="rect">
+            <a:avLst/>
+          </a:prstGeom>
+          <a:solidFill>
+            <a:srgbClr val="FFF3E8"/>
+          </a:solidFill>
+          <a:ln w="5080">
+            <a:solidFill>
+              <a:srgbClr val="CCCCCC"/>
+            </a:solidFill>
+          </a:ln>
+        </p:spPr>
+        <p:style>
+          <a:lnRef idx="1">
+            <a:schemeClr val="accent1"/>
+          </a:lnRef>
+          <a:fillRef idx="3">
+            <a:schemeClr val="accent1"/>
+          </a:fillRef>
+          <a:effectRef idx="2">
+            <a:schemeClr val="accent1"/>
+          </a:effectRef>
+          <a:fontRef idx="minor">
+            <a:schemeClr val="lt1"/>
+          </a:fontRef>
+        </p:style>
+        <p:txBody>
+          <a:bodyPr rtlCol="0" anchor="ctr"/>
+          <a:lstStyle/>
+          <a:p>
+            <a:pPr algn="ctr"/>
+          </a:p>
+        </p:txBody>
+      </p:sp>
+      <p:sp>
+        <p:nvSpPr>
+          <p:cNvPr id="43" name="TextBox 42"/>
+          <p:cNvSpPr txBox="1"/>
+          <p:nvPr/>
+        </p:nvSpPr>
+        <p:spPr>
+          <a:xfrm>
+            <a:off x="8769096" y="3429000"/>
+            <a:ext cx="2532888" cy="219456"/>
+          </a:xfrm>
+          <a:prstGeom prst="rect">
+            <a:avLst/>
+          </a:prstGeom>
+          <a:noFill/>
+        </p:spPr>
+        <p:txBody>
+          <a:bodyPr wrap="square">
+            <a:spAutoFit/>
+          </a:bodyPr>
+          <a:lstStyle/>
+          <a:p>
+            <a:pPr algn="l"/>
+            <a:r>
+              <a:rPr sz="1000" b="0" i="0">
+                <a:solidFill>
+                  <a:srgbClr val="1A1A1A"/>
+                </a:solidFill>
+              </a:rPr>
+              <a:t>↑ Enhanced growth</a:t>
+            </a:r>
+          </a:p>
+        </p:txBody>
+      </p:sp>
+      <p:sp>
+        <p:nvSpPr>
+          <p:cNvPr id="44" name="Rectangle 43"/>
+          <p:cNvSpPr/>
+          <p:nvPr/>
+        </p:nvSpPr>
+        <p:spPr>
+          <a:xfrm>
+            <a:off x="5669280" y="3694176"/>
+            <a:ext cx="1463040" cy="292608"/>
+          </a:xfrm>
+          <a:prstGeom prst="rect">
+            <a:avLst/>
+          </a:prstGeom>
+          <a:solidFill>
+            <a:srgbClr val="FFFFFF"/>
+          </a:solidFill>
+          <a:ln w="5080">
+            <a:solidFill>
+              <a:srgbClr val="CCCCCC"/>
+            </a:solidFill>
+          </a:ln>
+        </p:spPr>
+        <p:style>
+          <a:lnRef idx="1">
+            <a:schemeClr val="accent1"/>
+          </a:lnRef>
+          <a:fillRef idx="3">
+            <a:schemeClr val="accent1"/>
+          </a:fillRef>
+          <a:effectRef idx="2">
+            <a:schemeClr val="accent1"/>
+          </a:effectRef>
+          <a:fontRef idx="minor">
+            <a:schemeClr val="lt1"/>
+          </a:fontRef>
+        </p:style>
+        <p:txBody>
+          <a:bodyPr rtlCol="0" anchor="ctr"/>
+          <a:lstStyle/>
+          <a:p>
+            <a:pPr algn="ctr"/>
+          </a:p>
+        </p:txBody>
+      </p:sp>
+      <p:sp>
+        <p:nvSpPr>
+          <p:cNvPr id="45" name="TextBox 44"/>
+          <p:cNvSpPr txBox="1"/>
+          <p:nvPr/>
+        </p:nvSpPr>
+        <p:spPr>
+          <a:xfrm>
+            <a:off x="5715000" y="3739896"/>
+            <a:ext cx="1389888" cy="219456"/>
+          </a:xfrm>
+          <a:prstGeom prst="rect">
+            <a:avLst/>
+          </a:prstGeom>
+          <a:noFill/>
+        </p:spPr>
+        <p:txBody>
+          <a:bodyPr wrap="square">
+            <a:spAutoFit/>
+          </a:bodyPr>
+          <a:lstStyle/>
+          <a:p>
+            <a:pPr algn="l"/>
+            <a:r>
+              <a:rPr sz="1000" b="1" i="0">
+                <a:solidFill>
+                  <a:srgbClr val="C55A11"/>
+                </a:solidFill>
+              </a:rPr>
+              <a:t>GeneX</a:t>
+            </a:r>
+          </a:p>
+        </p:txBody>
+      </p:sp>
+      <p:sp>
+        <p:nvSpPr>
+          <p:cNvPr id="46" name="Rectangle 45"/>
+          <p:cNvSpPr/>
+          <p:nvPr/>
+        </p:nvSpPr>
+        <p:spPr>
+          <a:xfrm>
+            <a:off x="7150608" y="3694176"/>
+            <a:ext cx="1554480" cy="292608"/>
+          </a:xfrm>
+          <a:prstGeom prst="rect">
+            <a:avLst/>
+          </a:prstGeom>
+          <a:solidFill>
+            <a:srgbClr val="FFFFFF"/>
+          </a:solidFill>
+          <a:ln w="5080">
+            <a:solidFill>
+              <a:srgbClr val="CCCCCC"/>
+            </a:solidFill>
+          </a:ln>
+        </p:spPr>
+        <p:style>
+          <a:lnRef idx="1">
+            <a:schemeClr val="accent1"/>
+          </a:lnRef>
+          <a:fillRef idx="3">
+            <a:schemeClr val="accent1"/>
+          </a:fillRef>
+          <a:effectRef idx="2">
+            <a:schemeClr val="accent1"/>
+          </a:effectRef>
+          <a:fontRef idx="minor">
+            <a:schemeClr val="lt1"/>
+          </a:fontRef>
+        </p:style>
+        <p:txBody>
+          <a:bodyPr rtlCol="0" anchor="ctr"/>
+          <a:lstStyle/>
+          <a:p>
+            <a:pPr algn="ctr"/>
+          </a:p>
+        </p:txBody>
+      </p:sp>
+      <p:sp>
+        <p:nvSpPr>
+          <p:cNvPr id="47" name="TextBox 46"/>
+          <p:cNvSpPr txBox="1"/>
+          <p:nvPr/>
+        </p:nvSpPr>
+        <p:spPr>
+          <a:xfrm>
+            <a:off x="7196328" y="3739896"/>
+            <a:ext cx="1481328" cy="219456"/>
+          </a:xfrm>
+          <a:prstGeom prst="rect">
+            <a:avLst/>
+          </a:prstGeom>
+          <a:noFill/>
+        </p:spPr>
+        <p:txBody>
+          <a:bodyPr wrap="square">
+            <a:spAutoFit/>
+          </a:bodyPr>
+          <a:lstStyle/>
+          <a:p>
+            <a:pPr algn="ctr"/>
+            <a:r>
+              <a:rPr sz="1000" b="0" i="0">
+                <a:solidFill>
+                  <a:srgbClr val="C55A11"/>
+                </a:solidFill>
+              </a:rPr>
+              <a:t>124.5%</a:t>
+            </a:r>
+          </a:p>
+        </p:txBody>
+      </p:sp>
+      <p:sp>
+        <p:nvSpPr>
+          <p:cNvPr id="48" name="Rectangle 47"/>
+          <p:cNvSpPr/>
+          <p:nvPr/>
+        </p:nvSpPr>
+        <p:spPr>
+          <a:xfrm>
+            <a:off x="8723376" y="3694176"/>
+            <a:ext cx="2606040" cy="292608"/>
+          </a:xfrm>
+          <a:prstGeom prst="rect">
+            <a:avLst/>
+          </a:prstGeom>
+          <a:solidFill>
+            <a:srgbClr val="FFFFFF"/>
+          </a:solidFill>
+          <a:ln w="5080">
+            <a:solidFill>
+              <a:srgbClr val="CCCCCC"/>
+            </a:solidFill>
+          </a:ln>
+        </p:spPr>
+        <p:style>
+          <a:lnRef idx="1">
+            <a:schemeClr val="accent1"/>
+          </a:lnRef>
+          <a:fillRef idx="3">
+            <a:schemeClr val="accent1"/>
+          </a:fillRef>
+          <a:effectRef idx="2">
+            <a:schemeClr val="accent1"/>
+          </a:effectRef>
+          <a:fontRef idx="minor">
+            <a:schemeClr val="lt1"/>
+          </a:fontRef>
+        </p:style>
+        <p:txBody>
+          <a:bodyPr rtlCol="0" anchor="ctr"/>
+          <a:lstStyle/>
+          <a:p>
+            <a:pPr algn="ctr"/>
+          </a:p>
+        </p:txBody>
+      </p:sp>
+      <p:sp>
+        <p:nvSpPr>
+          <p:cNvPr id="49" name="TextBox 48"/>
+          <p:cNvSpPr txBox="1"/>
+          <p:nvPr/>
+        </p:nvSpPr>
+        <p:spPr>
+          <a:xfrm>
+            <a:off x="8769096" y="3739896"/>
+            <a:ext cx="2532888" cy="219456"/>
+          </a:xfrm>
+          <a:prstGeom prst="rect">
+            <a:avLst/>
+          </a:prstGeom>
+          <a:noFill/>
+        </p:spPr>
+        <p:txBody>
+          <a:bodyPr wrap="square">
+            <a:spAutoFit/>
+          </a:bodyPr>
+          <a:lstStyle/>
+          <a:p>
+            <a:pPr algn="l"/>
+            <a:r>
+              <a:rPr sz="1000" b="0" i="0">
+                <a:solidFill>
+                  <a:srgbClr val="1A1A1A"/>
+                </a:solidFill>
+              </a:rPr>
+              <a:t>↑ Enhanced growth</a:t>
+            </a:r>
+          </a:p>
+        </p:txBody>
+      </p:sp>
+      <p:sp>
+        <p:nvSpPr>
+          <p:cNvPr id="50" name="Rectangle 49"/>
+          <p:cNvSpPr/>
+          <p:nvPr/>
+        </p:nvSpPr>
+        <p:spPr>
+          <a:xfrm>
+            <a:off x="5669280" y="4005072"/>
+            <a:ext cx="1463040" cy="292608"/>
+          </a:xfrm>
+          <a:prstGeom prst="rect">
+            <a:avLst/>
+          </a:prstGeom>
+          <a:solidFill>
+            <a:srgbClr val="FFF3E8"/>
+          </a:solidFill>
+          <a:ln w="5080">
+            <a:solidFill>
+              <a:srgbClr val="CCCCCC"/>
+            </a:solidFill>
+          </a:ln>
+        </p:spPr>
+        <p:style>
+          <a:lnRef idx="1">
+            <a:schemeClr val="accent1"/>
+          </a:lnRef>
+          <a:fillRef idx="3">
+            <a:schemeClr val="accent1"/>
+          </a:fillRef>
+          <a:effectRef idx="2">
+            <a:schemeClr val="accent1"/>
+          </a:effectRef>
+          <a:fontRef idx="minor">
+            <a:schemeClr val="lt1"/>
+          </a:fontRef>
+        </p:style>
+        <p:txBody>
+          <a:bodyPr rtlCol="0" anchor="ctr"/>
+          <a:lstStyle/>
+          <a:p>
+            <a:pPr algn="ctr"/>
+          </a:p>
+        </p:txBody>
+      </p:sp>
+      <p:sp>
+        <p:nvSpPr>
+          <p:cNvPr id="51" name="TextBox 50"/>
+          <p:cNvSpPr txBox="1"/>
+          <p:nvPr/>
+        </p:nvSpPr>
+        <p:spPr>
+          <a:xfrm>
+            <a:off x="5715000" y="4050792"/>
+            <a:ext cx="1389888" cy="219456"/>
+          </a:xfrm>
+          <a:prstGeom prst="rect">
+            <a:avLst/>
+          </a:prstGeom>
+          <a:noFill/>
+        </p:spPr>
+        <p:txBody>
+          <a:bodyPr wrap="square">
+            <a:spAutoFit/>
+          </a:bodyPr>
+          <a:lstStyle/>
+          <a:p>
+            <a:pPr algn="l"/>
+            <a:r>
+              <a:rPr sz="1000" b="1" i="0">
+                <a:solidFill>
+                  <a:srgbClr val="C55A11"/>
+                </a:solidFill>
+              </a:rPr>
+              <a:t>GeneE</a:t>
+            </a:r>
+          </a:p>
+        </p:txBody>
+      </p:sp>
+      <p:sp>
+        <p:nvSpPr>
+          <p:cNvPr id="52" name="Rectangle 51"/>
+          <p:cNvSpPr/>
+          <p:nvPr/>
+        </p:nvSpPr>
+        <p:spPr>
+          <a:xfrm>
+            <a:off x="7150608" y="4005072"/>
+            <a:ext cx="1554480" cy="292608"/>
+          </a:xfrm>
+          <a:prstGeom prst="rect">
+            <a:avLst/>
+          </a:prstGeom>
+          <a:solidFill>
+            <a:srgbClr val="FFF3E8"/>
+          </a:solidFill>
+          <a:ln w="5080">
+            <a:solidFill>
+              <a:srgbClr val="CCCCCC"/>
+            </a:solidFill>
+          </a:ln>
+        </p:spPr>
+        <p:style>
+          <a:lnRef idx="1">
+            <a:schemeClr val="accent1"/>
+          </a:lnRef>
+          <a:fillRef idx="3">
+            <a:schemeClr val="accent1"/>
+          </a:fillRef>
+          <a:effectRef idx="2">
+            <a:schemeClr val="accent1"/>
+          </a:effectRef>
+          <a:fontRef idx="minor">
+            <a:schemeClr val="lt1"/>
+          </a:fontRef>
+        </p:style>
+        <p:txBody>
+          <a:bodyPr rtlCol="0" anchor="ctr"/>
+          <a:lstStyle/>
+          <a:p>
+            <a:pPr algn="ctr"/>
+          </a:p>
+        </p:txBody>
+      </p:sp>
+      <p:sp>
+        <p:nvSpPr>
+          <p:cNvPr id="53" name="TextBox 52"/>
+          <p:cNvSpPr txBox="1"/>
+          <p:nvPr/>
+        </p:nvSpPr>
+        <p:spPr>
+          <a:xfrm>
+            <a:off x="7196328" y="4050792"/>
+            <a:ext cx="1481328" cy="219456"/>
+          </a:xfrm>
+          <a:prstGeom prst="rect">
+            <a:avLst/>
+          </a:prstGeom>
+          <a:noFill/>
+        </p:spPr>
+        <p:txBody>
+          <a:bodyPr wrap="square">
+            <a:spAutoFit/>
+          </a:bodyPr>
+          <a:lstStyle/>
+          <a:p>
+            <a:pPr algn="ctr"/>
+            <a:r>
+              <a:rPr sz="1000" b="0" i="0">
+                <a:solidFill>
+                  <a:srgbClr val="C55A11"/>
+                </a:solidFill>
+              </a:rPr>
+              <a:t>124.0%</a:t>
+            </a:r>
+          </a:p>
+        </p:txBody>
+      </p:sp>
+      <p:sp>
+        <p:nvSpPr>
+          <p:cNvPr id="54" name="Rectangle 53"/>
+          <p:cNvSpPr/>
+          <p:nvPr/>
+        </p:nvSpPr>
+        <p:spPr>
+          <a:xfrm>
+            <a:off x="8723376" y="4005072"/>
+            <a:ext cx="2606040" cy="292608"/>
+          </a:xfrm>
+          <a:prstGeom prst="rect">
+            <a:avLst/>
+          </a:prstGeom>
+          <a:solidFill>
+            <a:srgbClr val="FFF3E8"/>
+          </a:solidFill>
+          <a:ln w="5080">
+            <a:solidFill>
+              <a:srgbClr val="CCCCCC"/>
+            </a:solidFill>
+          </a:ln>
+        </p:spPr>
+        <p:style>
+          <a:lnRef idx="1">
+            <a:schemeClr val="accent1"/>
+          </a:lnRef>
+          <a:fillRef idx="3">
+            <a:schemeClr val="accent1"/>
+          </a:fillRef>
+          <a:effectRef idx="2">
+            <a:schemeClr val="accent1"/>
+          </a:effectRef>
+          <a:fontRef idx="minor">
+            <a:schemeClr val="lt1"/>
+          </a:fontRef>
+        </p:style>
+        <p:txBody>
+          <a:bodyPr rtlCol="0" anchor="ctr"/>
+          <a:lstStyle/>
+          <a:p>
+            <a:pPr algn="ctr"/>
+          </a:p>
+        </p:txBody>
+      </p:sp>
+      <p:sp>
+        <p:nvSpPr>
+          <p:cNvPr id="55" name="TextBox 54"/>
+          <p:cNvSpPr txBox="1"/>
+          <p:nvPr/>
+        </p:nvSpPr>
+        <p:spPr>
+          <a:xfrm>
+            <a:off x="8769096" y="4050792"/>
+            <a:ext cx="2532888" cy="219456"/>
+          </a:xfrm>
+          <a:prstGeom prst="rect">
+            <a:avLst/>
+          </a:prstGeom>
+          <a:noFill/>
+        </p:spPr>
+        <p:txBody>
+          <a:bodyPr wrap="square">
+            <a:spAutoFit/>
+          </a:bodyPr>
+          <a:lstStyle/>
+          <a:p>
+            <a:pPr algn="l"/>
+            <a:r>
+              <a:rPr sz="1000" b="0" i="0">
+                <a:solidFill>
+                  <a:srgbClr val="1A1A1A"/>
+                </a:solidFill>
+              </a:rPr>
+              <a:t>↑ Enhanced growth</a:t>
+            </a:r>
+          </a:p>
+        </p:txBody>
+      </p:sp>
+      <p:sp>
+        <p:nvSpPr>
+          <p:cNvPr id="56" name="Rectangle 55"/>
+          <p:cNvSpPr/>
+          <p:nvPr/>
+        </p:nvSpPr>
+        <p:spPr>
+          <a:xfrm>
+            <a:off x="274320" y="3767328"/>
+            <a:ext cx="11640312" cy="2633472"/>
+          </a:xfrm>
+          <a:prstGeom prst="rect">
+            <a:avLst/>
+          </a:prstGeom>
+          <a:solidFill>
+            <a:srgbClr val="F5F9FF"/>
+          </a:solidFill>
+          <a:ln w="12700">
+            <a:solidFill>
+              <a:srgbClr val="2E75B6"/>
+            </a:solidFill>
+          </a:ln>
+        </p:spPr>
+        <p:style>
+          <a:lnRef idx="1">
+            <a:schemeClr val="accent1"/>
+          </a:lnRef>
+          <a:fillRef idx="3">
+            <a:schemeClr val="accent1"/>
+          </a:fillRef>
+          <a:effectRef idx="2">
+            <a:schemeClr val="accent1"/>
+          </a:effectRef>
+          <a:fontRef idx="minor">
+            <a:schemeClr val="lt1"/>
+          </a:fontRef>
+        </p:style>
+        <p:txBody>
+          <a:bodyPr rtlCol="0" anchor="ctr"/>
+          <a:lstStyle/>
+          <a:p>
+            <a:pPr algn="ctr"/>
+          </a:p>
+        </p:txBody>
+      </p:sp>
+      <p:sp>
+        <p:nvSpPr>
+          <p:cNvPr id="57" name="Rectangle 56"/>
+          <p:cNvSpPr/>
+          <p:nvPr/>
+        </p:nvSpPr>
+        <p:spPr>
+          <a:xfrm>
+            <a:off x="274320" y="3767328"/>
+            <a:ext cx="11640312" cy="475488"/>
+          </a:xfrm>
+          <a:prstGeom prst="rect">
+            <a:avLst/>
+          </a:prstGeom>
+          <a:solidFill>
+            <a:srgbClr val="2E75B6"/>
+          </a:solidFill>
+          <a:ln>
+            <a:noFill/>
+          </a:ln>
+        </p:spPr>
+        <p:style>
+          <a:lnRef idx="1">
+            <a:schemeClr val="accent1"/>
+          </a:lnRef>
+          <a:fillRef idx="3">
+            <a:schemeClr val="accent1"/>
+          </a:fillRef>
+          <a:effectRef idx="2">
+            <a:schemeClr val="accent1"/>
+          </a:effectRef>
+          <a:fontRef idx="minor">
+            <a:schemeClr val="lt1"/>
+          </a:fontRef>
+        </p:style>
+        <p:txBody>
+          <a:bodyPr rtlCol="0" anchor="ctr"/>
+          <a:lstStyle/>
+          <a:p>
+            <a:pPr algn="ctr"/>
+          </a:p>
+        </p:txBody>
+      </p:sp>
+      <p:sp>
+        <p:nvSpPr>
+          <p:cNvPr id="58" name="TextBox 57"/>
+          <p:cNvSpPr txBox="1"/>
+          <p:nvPr/>
+        </p:nvSpPr>
+        <p:spPr>
+          <a:xfrm>
+            <a:off x="457200" y="3840480"/>
+            <a:ext cx="8686800" cy="329184"/>
+          </a:xfrm>
+          <a:prstGeom prst="rect">
+            <a:avLst/>
+          </a:prstGeom>
+          <a:noFill/>
+        </p:spPr>
+        <p:txBody>
+          <a:bodyPr wrap="square">
+            <a:spAutoFit/>
+          </a:bodyPr>
+          <a:lstStyle/>
+          <a:p>
+            <a:pPr algn="l"/>
+            <a:r>
+              <a:rPr sz="1400" b="1" i="0">
+                <a:solidFill>
+                  <a:srgbClr val="FFFFFF"/>
+                </a:solidFill>
+              </a:rPr>
+              <a:t>Several Time Points  |  Multiple Controls  (23 time points, 3 h intervals, ~69 h total)</a:t>
+            </a:r>
+          </a:p>
+        </p:txBody>
+      </p:sp>
+      <p:sp>
+        <p:nvSpPr>
+          <p:cNvPr id="59" name="Rectangle 58"/>
+          <p:cNvSpPr/>
+          <p:nvPr/>
+        </p:nvSpPr>
+        <p:spPr>
+          <a:xfrm>
+            <a:off x="9601200" y="3858768"/>
+            <a:ext cx="2148840" cy="292608"/>
+          </a:xfrm>
+          <a:prstGeom prst="rect">
+            <a:avLst/>
+          </a:prstGeom>
+          <a:solidFill>
+            <a:srgbClr val="1F8678"/>
+          </a:solidFill>
+          <a:ln>
+            <a:noFill/>
+          </a:ln>
+        </p:spPr>
+        <p:style>
+          <a:lnRef idx="1">
+            <a:schemeClr val="accent1"/>
+          </a:lnRef>
+          <a:fillRef idx="3">
+            <a:schemeClr val="accent1"/>
+          </a:fillRef>
+          <a:effectRef idx="2">
+            <a:schemeClr val="accent1"/>
+          </a:effectRef>
+          <a:fontRef idx="minor">
+            <a:schemeClr val="lt1"/>
+          </a:fontRef>
+        </p:style>
+        <p:txBody>
+          <a:bodyPr rtlCol="0" anchor="ctr"/>
+          <a:lstStyle/>
+          <a:p>
+            <a:pPr algn="ctr"/>
+          </a:p>
+        </p:txBody>
+      </p:sp>
+      <p:sp>
+        <p:nvSpPr>
+          <p:cNvPr id="60" name="TextBox 59"/>
+          <p:cNvSpPr txBox="1"/>
+          <p:nvPr/>
+        </p:nvSpPr>
+        <p:spPr>
+          <a:xfrm>
+            <a:off x="9619488" y="3867912"/>
+            <a:ext cx="2112264" cy="256032"/>
+          </a:xfrm>
+          <a:prstGeom prst="rect">
+            <a:avLst/>
+          </a:prstGeom>
+          <a:noFill/>
+        </p:spPr>
+        <p:txBody>
+          <a:bodyPr wrap="square">
+            <a:spAutoFit/>
+          </a:bodyPr>
+          <a:lstStyle/>
+          <a:p>
+            <a:pPr algn="ctr"/>
+            <a:r>
+              <a:rPr sz="1100" b="1" i="0">
+                <a:solidFill>
+                  <a:srgbClr val="FFFFFF"/>
+                </a:solidFill>
+              </a:rPr>
+              <a:t>✅  COMPLETE</a:t>
+            </a:r>
+          </a:p>
+        </p:txBody>
+      </p:sp>
+      <p:sp>
+        <p:nvSpPr>
+          <p:cNvPr id="61" name="TextBox 60"/>
+          <p:cNvSpPr txBox="1"/>
+          <p:nvPr/>
+        </p:nvSpPr>
+        <p:spPr>
+          <a:xfrm>
+            <a:off x="457200" y="4315968"/>
+            <a:ext cx="11247120" cy="292608"/>
+          </a:xfrm>
+          <a:prstGeom prst="rect">
+            <a:avLst/>
+          </a:prstGeom>
+          <a:noFill/>
+        </p:spPr>
+        <p:txBody>
+          <a:bodyPr wrap="square">
+            <a:spAutoFit/>
+          </a:bodyPr>
+          <a:lstStyle/>
+          <a:p>
+            <a:pPr algn="l"/>
+            <a:r>
+              <a:rPr sz="1100" b="0" i="1">
+                <a:solidFill>
+                  <a:srgbClr val="1A375E"/>
+                </a:solidFill>
+              </a:rPr>
+              <a:t>Same perturbagens measured across time, enabling growth kinetics and rate calculations per target.</a:t>
+            </a:r>
+          </a:p>
+        </p:txBody>
+      </p:sp>
+      <p:sp>
+        <p:nvSpPr>
+          <p:cNvPr id="62" name="TextBox 61"/>
+          <p:cNvSpPr txBox="1"/>
+          <p:nvPr/>
+        </p:nvSpPr>
+        <p:spPr>
+          <a:xfrm>
+            <a:off x="457200" y="4663440"/>
+            <a:ext cx="7772400" cy="1627632"/>
+          </a:xfrm>
+          <a:prstGeom prst="rect">
+            <a:avLst/>
+          </a:prstGeom>
+          <a:noFill/>
+        </p:spPr>
+        <p:txBody>
+          <a:bodyPr wrap="square">
+            <a:spAutoFit/>
+          </a:bodyPr>
+          <a:lstStyle/>
           <a:p>
             <a:pPr>
               <a:spcBef>
@@ -9963,7 +11906,7 @@
                   <a:srgbClr val="1A1A1A"/>
                 </a:solidFill>
               </a:rPr>
-              <a:t>•  Single-timepoint readout — captures cumulative effect but not kinetics</a:t>
+              <a:t>•  Growth rate computed at each time point as a ratio to matched control</a:t>
             </a:r>
           </a:p>
           <a:p>
@@ -9978,20 +11921,65 @@
                   <a:srgbClr val="1A1A1A"/>
                 </a:solidFill>
               </a:rPr>
-              <a:t>•  Identifies candidate genes whose knockdown significantly alters cell proliferation</a:t>
-            </a:r>
-          </a:p>
-        </p:txBody>
-      </p:sp>
-      <p:sp>
-        <p:nvSpPr>
-          <p:cNvPr id="13" name="Rectangle 12"/>
+              <a:t>•  Growth rate &gt; 1.0 — cells proliferating faster (possible tumour suppressor knockdown)</a:t>
+            </a:r>
+          </a:p>
+          <a:p>
+            <a:pPr>
+              <a:spcBef>
+                <a:spcPts val="400"/>
+              </a:spcBef>
+            </a:pPr>
+            <a:r>
+              <a:rPr sz="1100">
+                <a:solidFill>
+                  <a:srgbClr val="1A1A1A"/>
+                </a:solidFill>
+              </a:rPr>
+              <a:t>•  Growth rate &lt; 1.0 — cells proliferating slower (growth-promoting gene silenced)</a:t>
+            </a:r>
+          </a:p>
+          <a:p>
+            <a:pPr>
+              <a:spcBef>
+                <a:spcPts val="400"/>
+              </a:spcBef>
+            </a:pPr>
+            <a:r>
+              <a:rPr sz="1100">
+                <a:solidFill>
+                  <a:srgbClr val="1A1A1A"/>
+                </a:solidFill>
+              </a:rPr>
+              <a:t>•  Multiple independent control groups enable robust plate-wide normalisation</a:t>
+            </a:r>
+          </a:p>
+          <a:p>
+            <a:pPr>
+              <a:spcBef>
+                <a:spcPts val="400"/>
+              </a:spcBef>
+            </a:pPr>
+            <a:r>
+              <a:rPr sz="1100">
+                <a:solidFill>
+                  <a:srgbClr val="1A1A1A"/>
+                </a:solidFill>
+              </a:rPr>
+              <a:t>•  Time-resolved data reveals whether effects are immediate, delayed, or transient</a:t>
+            </a:r>
+          </a:p>
+        </p:txBody>
+      </p:sp>
+      <p:sp>
+        <p:nvSpPr>
+          <p:cNvPr id="63" name="Rectangle 62"/>
           <p:cNvSpPr/>
           <p:nvPr/>
         </p:nvSpPr>
         <p:spPr>
           <a:xfrm>
-            <a:off x="8412480" y="1856232"/>
+            <a:off x="8412480" y="4636008"/>
             <a:ext cx="3337560" cy="1664208"/>
           </a:xfrm>
           <a:prstGeom prst="rect">
@@ -10030,13 +12018,13 @@
       </p:sp>
       <p:sp>
         <p:nvSpPr>
-          <p:cNvPr id="14" name="TextBox 13"/>
-          <p:cNvSpPr txBox="1"/>
-          <p:nvPr/>
-        </p:nvSpPr>
-        <p:spPr>
-          <a:xfrm>
-            <a:off x="8549640" y="1901952"/>
+          <p:cNvPr id="64" name="TextBox 63"/>
+          <p:cNvSpPr txBox="1"/>
+          <p:nvPr/>
+        </p:nvSpPr>
+        <p:spPr>
+          <a:xfrm>
+            <a:off x="8549640" y="4681728"/>
             <a:ext cx="3108960" cy="256032"/>
           </a:xfrm>
           <a:prstGeom prst="rect">
@@ -10064,13 +12052,13 @@
       </p:sp>
       <p:sp>
         <p:nvSpPr>
-          <p:cNvPr id="15" name="TextBox 14"/>
-          <p:cNvSpPr txBox="1"/>
-          <p:nvPr/>
-        </p:nvSpPr>
-        <p:spPr>
-          <a:xfrm>
-            <a:off x="8549640" y="2194560"/>
+          <p:cNvPr id="65" name="TextBox 64"/>
+          <p:cNvSpPr txBox="1"/>
+          <p:nvPr/>
+        </p:nvSpPr>
+        <p:spPr>
+          <a:xfrm>
+            <a:off x="8549640" y="4974336"/>
             <a:ext cx="3108960" cy="1261872"/>
           </a:xfrm>
           <a:prstGeom prst="rect">
@@ -10091,450 +12079,6 @@
                   <a:srgbClr val="1A1A1A"/>
                 </a:solidFill>
               </a:rPr>
-              <a:t>A straightforward binary screen: each perturbagen either hits or misses a growth phenotype. Genes showing strong deviation from 100% are prioritised for follow-up validation.</a:t>
-            </a:r>
-          </a:p>
-        </p:txBody>
-      </p:sp>
-      <p:sp>
-        <p:nvSpPr>
-          <p:cNvPr id="16" name="Rectangle 15"/>
-          <p:cNvSpPr/>
-          <p:nvPr/>
-        </p:nvSpPr>
-        <p:spPr>
-          <a:xfrm>
-            <a:off x="274320" y="3840480"/>
-            <a:ext cx="11640312" cy="2633472"/>
-          </a:xfrm>
-          <a:prstGeom prst="rect">
-            <a:avLst/>
-          </a:prstGeom>
-          <a:solidFill>
-            <a:srgbClr val="F5F9FF"/>
-          </a:solidFill>
-          <a:ln w="12700">
-            <a:solidFill>
-              <a:srgbClr val="2E75B6"/>
-            </a:solidFill>
-          </a:ln>
-        </p:spPr>
-        <p:style>
-          <a:lnRef idx="1">
-            <a:schemeClr val="accent1"/>
-          </a:lnRef>
-          <a:fillRef idx="3">
-            <a:schemeClr val="accent1"/>
-          </a:fillRef>
-          <a:effectRef idx="2">
-            <a:schemeClr val="accent1"/>
-          </a:effectRef>
-          <a:fontRef idx="minor">
-            <a:schemeClr val="lt1"/>
-          </a:fontRef>
-        </p:style>
-        <p:txBody>
-          <a:bodyPr rtlCol="0" anchor="ctr"/>
-          <a:lstStyle/>
-          <a:p>
-            <a:pPr algn="ctr"/>
-          </a:p>
-        </p:txBody>
-      </p:sp>
-      <p:sp>
-        <p:nvSpPr>
-          <p:cNvPr id="17" name="Rectangle 16"/>
-          <p:cNvSpPr/>
-          <p:nvPr/>
-        </p:nvSpPr>
-        <p:spPr>
-          <a:xfrm>
-            <a:off x="274320" y="3840480"/>
-            <a:ext cx="11640312" cy="475488"/>
-          </a:xfrm>
-          <a:prstGeom prst="rect">
-            <a:avLst/>
-          </a:prstGeom>
-          <a:solidFill>
-            <a:srgbClr val="2E75B6"/>
-          </a:solidFill>
-          <a:ln>
-            <a:noFill/>
-          </a:ln>
-        </p:spPr>
-        <p:style>
-          <a:lnRef idx="1">
-            <a:schemeClr val="accent1"/>
-          </a:lnRef>
-          <a:fillRef idx="3">
-            <a:schemeClr val="accent1"/>
-          </a:fillRef>
-          <a:effectRef idx="2">
-            <a:schemeClr val="accent1"/>
-          </a:effectRef>
-          <a:fontRef idx="minor">
-            <a:schemeClr val="lt1"/>
-          </a:fontRef>
-        </p:style>
-        <p:txBody>
-          <a:bodyPr rtlCol="0" anchor="ctr"/>
-          <a:lstStyle/>
-          <a:p>
-            <a:pPr algn="ctr"/>
-          </a:p>
-        </p:txBody>
-      </p:sp>
-      <p:sp>
-        <p:nvSpPr>
-          <p:cNvPr id="18" name="TextBox 17"/>
-          <p:cNvSpPr txBox="1"/>
-          <p:nvPr/>
-        </p:nvSpPr>
-        <p:spPr>
-          <a:xfrm>
-            <a:off x="457200" y="3913632"/>
-            <a:ext cx="8686800" cy="329184"/>
-          </a:xfrm>
-          <a:prstGeom prst="rect">
-            <a:avLst/>
-          </a:prstGeom>
-          <a:noFill/>
-        </p:spPr>
-        <p:txBody>
-          <a:bodyPr wrap="square">
-            <a:spAutoFit/>
-          </a:bodyPr>
-          <a:lstStyle/>
-          <a:p>
-            <a:pPr algn="l"/>
-            <a:r>
-              <a:rPr sz="1400" b="1" i="0">
-                <a:solidFill>
-                  <a:srgbClr val="FFFFFF"/>
-                </a:solidFill>
-              </a:rPr>
-              <a:t>Several Time Points  |  Multiple Controls  (23 time points, 3 h intervals, ~69 h total)</a:t>
-            </a:r>
-          </a:p>
-        </p:txBody>
-      </p:sp>
-      <p:sp>
-        <p:nvSpPr>
-          <p:cNvPr id="19" name="Rectangle 18"/>
-          <p:cNvSpPr/>
-          <p:nvPr/>
-        </p:nvSpPr>
-        <p:spPr>
-          <a:xfrm>
-            <a:off x="9601200" y="3931920"/>
-            <a:ext cx="2148840" cy="292608"/>
-          </a:xfrm>
-          <a:prstGeom prst="rect">
-            <a:avLst/>
-          </a:prstGeom>
-          <a:solidFill>
-            <a:srgbClr val="1F8678"/>
-          </a:solidFill>
-          <a:ln>
-            <a:noFill/>
-          </a:ln>
-        </p:spPr>
-        <p:style>
-          <a:lnRef idx="1">
-            <a:schemeClr val="accent1"/>
-          </a:lnRef>
-          <a:fillRef idx="3">
-            <a:schemeClr val="accent1"/>
-          </a:fillRef>
-          <a:effectRef idx="2">
-            <a:schemeClr val="accent1"/>
-          </a:effectRef>
-          <a:fontRef idx="minor">
-            <a:schemeClr val="lt1"/>
-          </a:fontRef>
-        </p:style>
-        <p:txBody>
-          <a:bodyPr rtlCol="0" anchor="ctr"/>
-          <a:lstStyle/>
-          <a:p>
-            <a:pPr algn="ctr"/>
-          </a:p>
-        </p:txBody>
-      </p:sp>
-      <p:sp>
-        <p:nvSpPr>
-          <p:cNvPr id="20" name="TextBox 19"/>
-          <p:cNvSpPr txBox="1"/>
-          <p:nvPr/>
-        </p:nvSpPr>
-        <p:spPr>
-          <a:xfrm>
-            <a:off x="9619488" y="3941064"/>
-            <a:ext cx="2112264" cy="256032"/>
-          </a:xfrm>
-          <a:prstGeom prst="rect">
-            <a:avLst/>
-          </a:prstGeom>
-          <a:noFill/>
-        </p:spPr>
-        <p:txBody>
-          <a:bodyPr wrap="square">
-            <a:spAutoFit/>
-          </a:bodyPr>
-          <a:lstStyle/>
-          <a:p>
-            <a:pPr algn="ctr"/>
-            <a:r>
-              <a:rPr sz="1100" b="1" i="0">
-                <a:solidFill>
-                  <a:srgbClr val="FFFFFF"/>
-                </a:solidFill>
-              </a:rPr>
-              <a:t>✅  COMPLETE</a:t>
-            </a:r>
-          </a:p>
-        </p:txBody>
-      </p:sp>
-      <p:sp>
-        <p:nvSpPr>
-          <p:cNvPr id="21" name="TextBox 20"/>
-          <p:cNvSpPr txBox="1"/>
-          <p:nvPr/>
-        </p:nvSpPr>
-        <p:spPr>
-          <a:xfrm>
-            <a:off x="457200" y="4389120"/>
-            <a:ext cx="11338560" cy="292608"/>
-          </a:xfrm>
-          <a:prstGeom prst="rect">
-            <a:avLst/>
-          </a:prstGeom>
-          <a:noFill/>
-        </p:spPr>
-        <p:txBody>
-          <a:bodyPr wrap="square">
-            <a:spAutoFit/>
-          </a:bodyPr>
-          <a:lstStyle/>
-          <a:p>
-            <a:pPr algn="l"/>
-            <a:r>
-              <a:rPr sz="1100" b="0" i="1">
-                <a:solidFill>
-                  <a:srgbClr val="1A375E"/>
-                </a:solidFill>
-              </a:rPr>
-              <a:t>Same perturbagens measured across time, enabling growth kinetics and rate calculations</a:t>
-            </a:r>
-          </a:p>
-        </p:txBody>
-      </p:sp>
-      <p:sp>
-        <p:nvSpPr>
-          <p:cNvPr id="22" name="TextBox 21"/>
-          <p:cNvSpPr txBox="1"/>
-          <p:nvPr/>
-        </p:nvSpPr>
-        <p:spPr>
-          <a:xfrm>
-            <a:off x="457200" y="4736592"/>
-            <a:ext cx="7772400" cy="1600200"/>
-          </a:xfrm>
-          <a:prstGeom prst="rect">
-            <a:avLst/>
-          </a:prstGeom>
-          <a:noFill/>
-        </p:spPr>
-        <p:txBody>
-          <a:bodyPr wrap="square">
-            <a:spAutoFit/>
-          </a:bodyPr>
-          <a:lstStyle/>
-          <a:p>
-            <a:pPr>
-              <a:spcBef>
-                <a:spcPts val="400"/>
-              </a:spcBef>
-            </a:pPr>
-            <a:r>
-              <a:rPr sz="1100">
-                <a:solidFill>
-                  <a:srgbClr val="1A1A1A"/>
-                </a:solidFill>
-              </a:rPr>
-              <a:t>•  Growth rate computed at each time point as a ratio to the matched control group</a:t>
-            </a:r>
-          </a:p>
-          <a:p>
-            <a:pPr>
-              <a:spcBef>
-                <a:spcPts val="400"/>
-              </a:spcBef>
-            </a:pPr>
-            <a:r>
-              <a:rPr sz="1100">
-                <a:solidFill>
-                  <a:srgbClr val="1A1A1A"/>
-                </a:solidFill>
-              </a:rPr>
-              <a:t>•  Growth rate &gt; 1.0 — cells proliferating faster than control (possible tumour suppressor knockdown)</a:t>
-            </a:r>
-          </a:p>
-          <a:p>
-            <a:pPr>
-              <a:spcBef>
-                <a:spcPts val="400"/>
-              </a:spcBef>
-            </a:pPr>
-            <a:r>
-              <a:rPr sz="1100">
-                <a:solidFill>
-                  <a:srgbClr val="1A1A1A"/>
-                </a:solidFill>
-              </a:rPr>
-              <a:t>•  Growth rate &lt; 1.0 — cells proliferating slower than control (growth-promoting gene silenced)</a:t>
-            </a:r>
-          </a:p>
-          <a:p>
-            <a:pPr>
-              <a:spcBef>
-                <a:spcPts val="400"/>
-              </a:spcBef>
-            </a:pPr>
-            <a:r>
-              <a:rPr sz="1100">
-                <a:solidFill>
-                  <a:srgbClr val="1A1A1A"/>
-                </a:solidFill>
-              </a:rPr>
-              <a:t>•  Multiple independent control groups enable robust plate-wide normalisation</a:t>
-            </a:r>
-          </a:p>
-          <a:p>
-            <a:pPr>
-              <a:spcBef>
-                <a:spcPts val="400"/>
-              </a:spcBef>
-            </a:pPr>
-            <a:r>
-              <a:rPr sz="1100">
-                <a:solidFill>
-                  <a:srgbClr val="1A1A1A"/>
-                </a:solidFill>
-              </a:rPr>
-              <a:t>•  Time-resolved data reveals whether effects are immediate, delayed, or transient</a:t>
-            </a:r>
-          </a:p>
-        </p:txBody>
-      </p:sp>
-      <p:sp>
-        <p:nvSpPr>
-          <p:cNvPr id="23" name="Rectangle 22"/>
-          <p:cNvSpPr/>
-          <p:nvPr/>
-        </p:nvSpPr>
-        <p:spPr>
-          <a:xfrm>
-            <a:off x="8412480" y="4709160"/>
-            <a:ext cx="3337560" cy="1664208"/>
-          </a:xfrm>
-          <a:prstGeom prst="rect">
-            <a:avLst/>
-          </a:prstGeom>
-          <a:solidFill>
-            <a:srgbClr val="FFFFFF"/>
-          </a:solidFill>
-          <a:ln w="10160">
-            <a:solidFill>
-              <a:srgbClr val="2E75B6"/>
-            </a:solidFill>
-          </a:ln>
-        </p:spPr>
-        <p:style>
-          <a:lnRef idx="1">
-            <a:schemeClr val="accent1"/>
-          </a:lnRef>
-          <a:fillRef idx="3">
-            <a:schemeClr val="accent1"/>
-          </a:fillRef>
-          <a:effectRef idx="2">
-            <a:schemeClr val="accent1"/>
-          </a:effectRef>
-          <a:fontRef idx="minor">
-            <a:schemeClr val="lt1"/>
-          </a:fontRef>
-        </p:style>
-        <p:txBody>
-          <a:bodyPr rtlCol="0" anchor="ctr"/>
-          <a:lstStyle/>
-          <a:p>
-            <a:pPr algn="ctr"/>
-          </a:p>
-        </p:txBody>
-      </p:sp>
-      <p:sp>
-        <p:nvSpPr>
-          <p:cNvPr id="24" name="TextBox 23"/>
-          <p:cNvSpPr txBox="1"/>
-          <p:nvPr/>
-        </p:nvSpPr>
-        <p:spPr>
-          <a:xfrm>
-            <a:off x="8549640" y="4754880"/>
-            <a:ext cx="3108960" cy="256032"/>
-          </a:xfrm>
-          <a:prstGeom prst="rect">
-            <a:avLst/>
-          </a:prstGeom>
-          <a:noFill/>
-        </p:spPr>
-        <p:txBody>
-          <a:bodyPr wrap="square">
-            <a:spAutoFit/>
-          </a:bodyPr>
-          <a:lstStyle/>
-          <a:p>
-            <a:pPr algn="l"/>
-            <a:r>
-              <a:rPr sz="1000" b="1" i="0">
-                <a:solidFill>
-                  <a:srgbClr val="2E75B6"/>
-                </a:solidFill>
-              </a:rPr>
-              <a:t>Interpretation</a:t>
-            </a:r>
-          </a:p>
-        </p:txBody>
-      </p:sp>
-      <p:sp>
-        <p:nvSpPr>
-          <p:cNvPr id="25" name="TextBox 24"/>
-          <p:cNvSpPr txBox="1"/>
-          <p:nvPr/>
-        </p:nvSpPr>
-        <p:spPr>
-          <a:xfrm>
-            <a:off x="8549640" y="5047488"/>
-            <a:ext cx="3108960" cy="1261872"/>
-          </a:xfrm>
-          <a:prstGeom prst="rect">
-            <a:avLst/>
-          </a:prstGeom>
-          <a:noFill/>
-        </p:spPr>
-        <p:txBody>
-          <a:bodyPr wrap="square">
-            <a:spAutoFit/>
-          </a:bodyPr>
-          <a:lstStyle/>
-          <a:p>
-            <a:pPr algn="l"/>
-            <a:r>
-              <a:rPr sz="1000" b="0" i="1">
-                <a:solidFill>
-                  <a:srgbClr val="1A1A1A"/>
-                </a:solidFill>
-              </a:rPr>
               <a:t>Time-course data provides richer biological insight than endpoint alone — a perturbagen with a delayed growth rate change may reflect an indirect or adaptive cellular response.</a:t>
             </a:r>
           </a:p>
@@ -10542,89 +12086,7 @@
       </p:sp>
       <p:sp>
         <p:nvSpPr>
-          <p:cNvPr id="26" name="Rectangle 25"/>
-          <p:cNvSpPr/>
-          <p:nvPr/>
-        </p:nvSpPr>
-        <p:spPr>
-          <a:xfrm>
-            <a:off x="274320" y="6473952"/>
-            <a:ext cx="11640312" cy="0"/>
-          </a:xfrm>
-          <a:prstGeom prst="rect">
-            <a:avLst/>
-          </a:prstGeom>
-          <a:noFill/>
-          <a:ln>
-            <a:noFill/>
-          </a:ln>
-        </p:spPr>
-        <p:style>
-          <a:lnRef idx="1">
-            <a:schemeClr val="accent1"/>
-          </a:lnRef>
-          <a:fillRef idx="3">
-            <a:schemeClr val="accent1"/>
-          </a:fillRef>
-          <a:effectRef idx="2">
-            <a:schemeClr val="accent1"/>
-          </a:effectRef>
-          <a:fontRef idx="minor">
-            <a:schemeClr val="lt1"/>
-          </a:fontRef>
-        </p:style>
-        <p:txBody>
-          <a:bodyPr rtlCol="0" anchor="ctr"/>
-          <a:lstStyle/>
-          <a:p>
-            <a:pPr algn="ctr"/>
-          </a:p>
-        </p:txBody>
-      </p:sp>
-      <p:sp>
-        <p:nvSpPr>
-          <p:cNvPr id="27" name="Rectangle 26"/>
-          <p:cNvSpPr/>
-          <p:nvPr/>
-        </p:nvSpPr>
-        <p:spPr>
-          <a:xfrm>
-            <a:off x="274320" y="6473952"/>
-            <a:ext cx="6400800" cy="0"/>
-          </a:xfrm>
-          <a:prstGeom prst="rect">
-            <a:avLst/>
-          </a:prstGeom>
-          <a:noFill/>
-          <a:ln>
-            <a:noFill/>
-          </a:ln>
-        </p:spPr>
-        <p:style>
-          <a:lnRef idx="1">
-            <a:schemeClr val="accent1"/>
-          </a:lnRef>
-          <a:fillRef idx="3">
-            <a:schemeClr val="accent1"/>
-          </a:fillRef>
-          <a:effectRef idx="2">
-            <a:schemeClr val="accent1"/>
-          </a:effectRef>
-          <a:fontRef idx="minor">
-            <a:schemeClr val="lt1"/>
-          </a:fontRef>
-        </p:style>
-        <p:txBody>
-          <a:bodyPr rtlCol="0" anchor="ctr"/>
-          <a:lstStyle/>
-          <a:p>
-            <a:pPr algn="ctr"/>
-          </a:p>
-        </p:txBody>
-      </p:sp>
-      <p:sp>
-        <p:nvSpPr>
-          <p:cNvPr id="28" name="Rectangle 27"/>
+          <p:cNvPr id="66" name="Rectangle 65"/>
           <p:cNvSpPr/>
           <p:nvPr/>
         </p:nvSpPr>
@@ -10667,7 +12129,7 @@
       </p:sp>
       <p:sp>
         <p:nvSpPr>
-          <p:cNvPr id="29" name="TextBox 28"/>
+          <p:cNvPr id="67" name="TextBox 66"/>
           <p:cNvSpPr txBox="1"/>
           <p:nvPr/>
         </p:nvSpPr>
@@ -10701,7 +12163,7 @@
       </p:sp>
       <p:sp>
         <p:nvSpPr>
-          <p:cNvPr id="30" name="TextBox 29"/>
+          <p:cNvPr id="68" name="TextBox 67"/>
           <p:cNvSpPr txBox="1"/>
           <p:nvPr/>
         </p:nvSpPr>

</xml_diff>